<commit_message>
Put Justin N9HO on the talk title slide
Co-Authored-By: Claude Fable 5.1 <noreply@anthropic.com>
Claude-Session: https://claude.ai/code/session_01KDZck9uBeSHBv7szzYQxJN
</commit_message>
<xml_diff>
--- a/docs/talks/quansheng-2m-cw/quansheng-2m-cw.pptx
+++ b/docs/talks/quansheng-2m-cw/quansheng-2m-cw.pptx
@@ -1224,7 +1224,7 @@
           <a:p>
             <a:r>
               <a:rPr lang="en-US" dirty="0"/>
-              <a:t>Lighten it up before the closer. The gang keeps a 'days since we broke a Quansheng' sign on the website with an incident log, names named. Three so far. Each one maps to a step you just saw: pry at the right edge, heat instead of pull, and door before ribbon. If you break one tonight you confess on Discord and an officer resets the sign.</a:t>
+              <a:t>Lighten it up before the closer. The gang keeps a 'days since we broke a Quansheng' sign on the website with an incident log, names named. Three so far, and incident number one is you, so own it: that is the whole point of the board. Each one maps to a step you just saw: pry at the right edge, heat instead of pull, and door before ribbon. If you break one tonight you confess on Discord and an officer resets the sign.</a:t>
             </a:r>
             <a:endParaRPr lang="en-US" dirty="0"/>
           </a:p>
@@ -2641,7 +2641,7 @@
                 <a:ea typeface="Calibri" pitchFamily="34" charset="-122"/>
                 <a:cs typeface="Calibri" pitchFamily="34" charset="-120"/>
               </a:rPr>
-              <a:t>Presenter: Your Name · CALLSIGN</a:t>
+              <a:t>Justin · N9HO</a:t>
             </a:r>
             <a:endParaRPr lang="en-US" sz="1600" dirty="0"/>
           </a:p>

</xml_diff>

<commit_message>
Give the talk deck's wire lengths in inches
Co-Authored-By: Claude Fable 5.1 <noreply@anthropic.com>
Claude-Session: https://claude.ai/code/session_01KDZck9uBeSHBv7szzYQxJN
</commit_message>
<xml_diff>
--- a/docs/talks/quansheng-2m-cw/quansheng-2m-cw.pptx
+++ b/docs/talks/quansheng-2m-cw/quansheng-2m-cw.pptx
@@ -784,7 +784,7 @@
           <a:p>
             <a:r>
               <a:rPr lang="en-US" dirty="0"/>
-              <a:t>Two wires, roughly 50 and 80 millimeters. Follow the photo: the blue wire runs from the solder blob on the left edge over to the pad near the resistor site by the jack, and the yellow wire runs from the headset jack pad down to gold pad number three of the four on the bottom edge, which is the SWDIO pad. Route the long one to the side of the button pads so it never sits under a key, and keep both flat so the display drops back over them. Stranded wire works but watch for stray strands at each end.</a:t>
+              <a:t>Two wires, roughly two and three inches. Follow the photo: the blue wire runs from the solder blob on the left edge over to the pad near the resistor site by the jack, and the yellow wire runs from the headset jack pad down to gold pad number three of the four on the bottom edge, which is the SWDIO pad. Route the long one to the side of the button pads so it never sits under a key, and keep both flat so the display drops back over them. Stranded wire works but watch for stray strands at each end.</a:t>
             </a:r>
             <a:endParaRPr lang="en-US" dirty="0"/>
           </a:p>
@@ -4792,7 +4792,7 @@
                 <a:ea typeface="Calibri" pitchFamily="34" charset="-122"/>
                 <a:cs typeface="Calibri" pitchFamily="34" charset="-120"/>
               </a:rPr>
-              <a:t>About 50 mm and 80 mm of anything 22 AWG or thinner. Tin the ends first.</a:t>
+              <a:t>About 2 in and 3 in of anything 22 AWG or thinner. Tin the ends first.</a:t>
             </a:r>
             <a:endParaRPr lang="en-US" sz="1600" dirty="0"/>
           </a:p>
@@ -4961,7 +4961,7 @@
                 <a:ea typeface="Calibri" pitchFamily="34" charset="-122"/>
                 <a:cs typeface="Calibri" pitchFamily="34" charset="-120"/>
               </a:rPr>
-              <a:t>Short wire (blue, ~50 mm)</a:t>
+              <a:t>Short wire (blue, ~2 in)</a:t>
             </a:r>
             <a:endParaRPr lang="en-US" sz="1600" dirty="0"/>
           </a:p>
@@ -5109,7 +5109,7 @@
                 <a:ea typeface="Calibri" pitchFamily="34" charset="-122"/>
                 <a:cs typeface="Calibri" pitchFamily="34" charset="-120"/>
               </a:rPr>
-              <a:t>Long wire (yellow, ~80 mm)</a:t>
+              <a:t>Long wire (yellow, ~3 in)</a:t>
             </a:r>
             <a:endParaRPr lang="en-US" sz="1600" dirty="0"/>
           </a:p>
@@ -19764,7 +19764,7 @@
                 <a:ea typeface="Calibri" pitchFamily="34" charset="-122"/>
                 <a:cs typeface="Calibri" pitchFamily="34" charset="-120"/>
               </a:rPr>
-              <a:t>Two wires, about 50 mm and 80 mm, 22 AWG or thinner. Strip them out of the USB cable in the box.</a:t>
+              <a:t>Two wires, about 2 in and 3 in, 22 AWG or thinner. Strip them out of the USB cable in the box.</a:t>
             </a:r>
             <a:endParaRPr lang="en-US" sz="1400" dirty="0"/>
           </a:p>

</xml_diff>

<commit_message>
Frame the talk deck as a pitch, not a build night
Co-Authored-By: Claude Fable 5.1 <noreply@anthropic.com>
Claude-Session: https://claude.ai/code/session_01KDZck9uBeSHBv7szzYQxJN
</commit_message>
<xml_diff>
--- a/docs/talks/quansheng-2m-cw/quansheng-2m-cw.pptx
+++ b/docs/talks/quansheng-2m-cw/quansheng-2m-cw.pptx
@@ -520,7 +520,7 @@
           <a:p>
             <a:r>
               <a:rPr lang="en-US" dirty="0"/>
-              <a:t>Open with the radio in your hand. Hold it up. Tell them it cost thirty dollars, it does real CW, and by the end of the night they will know how to build one. Tonight is about one goal: more operators sending Morse on 2 meters than there were last year. Everything else is a side effect.</a:t>
+              <a:t>Open with the radio in your hand. Hold it up. Tell them it cost thirty dollars, it does real CW, and the goal is that they go home wanting to build one. This is a pitch, not a build night: nobody is soldering tonight. It is about one goal: more operators sending Morse on 2 meters than there were last year. Everything else is a side effect.</a:t>
             </a:r>
             <a:endParaRPr lang="en-US" dirty="0"/>
           </a:p>
@@ -1224,7 +1224,7 @@
           <a:p>
             <a:r>
               <a:rPr lang="en-US" dirty="0"/>
-              <a:t>Lighten it up before the closer. The gang keeps a 'days since we broke a Quansheng' sign on the website with an incident log, names named. Three so far, and incident number one is you, so own it: that is the whole point of the board. Each one maps to a step you just saw: pry at the right edge, heat instead of pull, and door before ribbon. If you break one tonight you confess on Discord and an officer resets the sign.</a:t>
+              <a:t>Lighten it up before the closer. The gang keeps a 'days since we broke a Quansheng' sign on the website with an incident log, names named. Three so far, and incident number one is you, so own it: that is the whole point of the board. Each one maps to a step you just saw: pry at the right edge, heat instead of pull, and door before ribbon. If you break one, you confess on Discord and an officer resets the sign.</a:t>
             </a:r>
             <a:endParaRPr lang="en-US" dirty="0"/>
           </a:p>
@@ -1488,7 +1488,7 @@
           <a:p>
             <a:r>
               <a:rPr lang="en-US" dirty="0"/>
-              <a:t>Roadmap. Spend most of the time on the middle three: the firmware, the mod, and getting on the air. The gang is the closer, keep it to a couple of minutes.</a:t>
+              <a:t>Roadmap. This is an interest talk, not a workshop, so keep the rework steps brisk and visual. Spend most of the time on the middle three: the firmware, the mod, and getting on the air. The gang is the closer, keep it to a couple of minutes.</a:t>
             </a:r>
             <a:endParaRPr lang="en-US" dirty="0"/>
           </a:p>
@@ -1928,7 +1928,7 @@
           <a:p>
             <a:r>
               <a:rPr lang="en-US" dirty="0"/>
-              <a:t>You do not have to open the radio to try this. PTT and side button works on a stock radio the day you flash it. The USB-C cable is a passive custom cable, no electronics, but it is very sensitive to RF from your own transmitter and can lock into key-down. The rework is what we are doing tonight: any off-the-shelf paddle plugs straight into the headset jack.</a:t>
+              <a:t>You do not have to open the radio to try this. PTT and side button works on a stock radio the day you flash it. The USB-C cable is a passive custom cable, no electronics, but it is very sensitive to RF from your own transmitter and can lock into key-down. The rework is what the rest of the talk walks through: any off-the-shelf paddle plugs straight into the headset jack.</a:t>
             </a:r>
             <a:endParaRPr lang="en-US" dirty="0"/>
           </a:p>
@@ -4057,7 +4057,7 @@
                 <a:ea typeface="Calibri" pitchFamily="34" charset="-122"/>
                 <a:cs typeface="Calibri" pitchFamily="34" charset="-120"/>
               </a:rPr>
-              <a:t>The steadiest hands in the room take the first one. Everyone else crowds around.</a:t>
+              <a:t>The only step that needs a steady hand. Two tiny parts, one careful minute.</a:t>
             </a:r>
             <a:endParaRPr lang="en-US" sz="1600" dirty="0"/>
           </a:p>
@@ -15422,7 +15422,7 @@
                 <a:ea typeface="Calibri" pitchFamily="34" charset="-122"/>
                 <a:cs typeface="Calibri" pitchFamily="34" charset="-120"/>
               </a:rPr>
-              <a:t>Sold everywhere, so a build night can order five identical radios.</a:t>
+              <a:t>Sold everywhere, so a club build night could order five identical radios.</a:t>
             </a:r>
             <a:endParaRPr lang="en-US" sz="1400" dirty="0"/>
           </a:p>
@@ -18435,7 +18435,7 @@
                 <a:ea typeface="Calibri" pitchFamily="34" charset="-122"/>
                 <a:cs typeface="Calibri" pitchFamily="34" charset="-120"/>
               </a:rPr>
-              <a:t>Pick by how much you want to open the radio. Tonight we do the third one.</a:t>
+              <a:t>Pick by how much you want to open the radio. The rest of this talk walks through the third one.</a:t>
             </a:r>
             <a:endParaRPr lang="en-US" sz="1600" dirty="0"/>
           </a:p>

</xml_diff>

<commit_message>
Update the talk deck's BKG member count to 400+
Co-Authored-By: Claude Fable 5.1 <noreply@anthropic.com>
Claude-Session: https://claude.ai/code/session_01KDZck9uBeSHBv7szzYQxJN
</commit_message>
<xml_diff>
--- a/docs/talks/quansheng-2m-cw/quansheng-2m-cw.pptx
+++ b/docs/talks/quansheng-2m-cw/quansheng-2m-cw.pptx
@@ -1312,7 +1312,7 @@
           <a:p>
             <a:r>
               <a:rPr lang="en-US" dirty="0"/>
-              <a:t>Closer, two minutes. The Brass Knuckle Gang: pounding brass means sending Morse on a manual key. Founded 2025 in Northern Utah, now thirty members and worldwide. A law-abiding, FCC-respecting gang, and we mean the second part as sincerely as the first. Three bylaws. To join you work an existing member on 2 meter CW, give them the UTC date and time, and you get a number. Membership is voluntary every time; confirm someone wants in before you submit them.</a:t>
+              <a:t>Closer, two minutes. The Brass Knuckle Gang: pounding brass means sending Morse on a manual key. Founded 2025 in Northern Utah, now over four hundred members and worldwide. A law-abiding, FCC-respecting gang, and we mean the second part as sincerely as the first. Three bylaws. To join you work an existing member on 2 meter CW, give them the UTC date and time, and you get a number. Membership is voluntary every time; confirm someone wants in before you submit them.</a:t>
             </a:r>
             <a:endParaRPr lang="en-US" dirty="0"/>
           </a:p>
@@ -11070,7 +11070,7 @@
                 <a:ea typeface="Calibri" pitchFamily="34" charset="-122"/>
                 <a:cs typeface="Calibri" pitchFamily="34" charset="-120"/>
               </a:rPr>
-              <a:t>30 and recruiting</a:t>
+              <a:t>400+ and recruiting</a:t>
             </a:r>
             <a:endParaRPr lang="en-US" sz="1100" dirty="0"/>
           </a:p>

</xml_diff>

<commit_message>
Refresh the talk deck's gang numbers from today's site build
458 members, 42 states, 7 DX countries per the September 12 deploy log.
Also links the intro video and nearby finder on the closing slide.

Co-Authored-By: Claude Fable 5.1 <noreply@anthropic.com>
Claude-Session: https://claude.ai/code/session_01KDZck9uBeSHBv7szzYQxJN
</commit_message>
<xml_diff>
--- a/docs/talks/quansheng-2m-cw/quansheng-2m-cw.pptx
+++ b/docs/talks/quansheng-2m-cw/quansheng-2m-cw.pptx
@@ -1312,7 +1312,7 @@
           <a:p>
             <a:r>
               <a:rPr lang="en-US" dirty="0"/>
-              <a:t>Closer, two minutes. The Brass Knuckle Gang: pounding brass means sending Morse on a manual key. Founded 2025 in Northern Utah, now over four hundred members and worldwide. A law-abiding, FCC-respecting gang, and we mean the second part as sincerely as the first. Three bylaws. To join you work an existing member on 2 meter CW, give them the UTC date and time, and you get a number. Membership is voluntary every time; confirm someone wants in before you submit them.</a:t>
+              <a:t>Closer, two minutes. The Brass Knuckle Gang: pounding brass means sending Morse on a manual key. Founded 2025 in Northern Utah. As of today's site build there are 458 members across 42 states and 7 other countries, and the firmware author NR7Y is on the roster himself. A law-abiding, FCC-respecting gang, and we mean the second part as sincerely as the first. Three bylaws. To join you work an existing member on 2 meter CW, give them the UTC date and time, and you get a number. Membership is voluntary every time; confirm someone wants in before you submit them.</a:t>
             </a:r>
             <a:endParaRPr lang="en-US" dirty="0"/>
           </a:p>
@@ -1664,7 +1664,7 @@
           <a:p>
             <a:r>
               <a:rPr lang="en-US" dirty="0"/>
-              <a:t>The stock radio will not send CW at all. What makes it interesting is the open-source lineage: DualTachyon reverse engineered the original K5 and released the first open firmware, egzumer built the feature-rich custom firmware everyone knows, F4HWN and muzkr ported it to the newer K5 v3 and K1 hardware as Fusion, and NR7Y layered a real CW transceiver on top of that. All Apache 2.0.</a:t>
+              <a:t>The stock radio will not send CW at all. What makes it interesting is the open-source lineage: DualTachyon reverse engineered the original K5 and released the first open firmware, egzumer built the feature-rich custom firmware everyone knows, F4HWN and muzkr ported it to the newer K5 v3 and K1 hardware as Fusion, and NR7Y layered a real CW transceiver on top of that. All Apache 2.0. NR7Y is also a BKG member, which is a nice line to drop here.</a:t>
             </a:r>
             <a:endParaRPr lang="en-US" dirty="0"/>
           </a:p>
@@ -10832,7 +10832,7 @@
         </p:nvSpPr>
         <p:spPr>
           <a:xfrm>
-            <a:off x="548640" y="5303520"/>
+            <a:off x="548640" y="5230368"/>
             <a:ext cx="1097280" cy="246888"/>
           </a:xfrm>
           <a:prstGeom prst="rect">
@@ -10874,7 +10874,7 @@
         </p:nvSpPr>
         <p:spPr>
           <a:xfrm>
-            <a:off x="1645920" y="5303520"/>
+            <a:off x="1645920" y="5230368"/>
             <a:ext cx="2377440" cy="246888"/>
           </a:xfrm>
           <a:prstGeom prst="rect">
@@ -10916,7 +10916,7 @@
         </p:nvSpPr>
         <p:spPr>
           <a:xfrm>
-            <a:off x="548640" y="5550408"/>
+            <a:off x="548640" y="5477256"/>
             <a:ext cx="1097280" cy="246888"/>
           </a:xfrm>
           <a:prstGeom prst="rect">
@@ -10958,7 +10958,7 @@
         </p:nvSpPr>
         <p:spPr>
           <a:xfrm>
-            <a:off x="1645920" y="5550408"/>
+            <a:off x="1645920" y="5477256"/>
             <a:ext cx="2377440" cy="246888"/>
           </a:xfrm>
           <a:prstGeom prst="rect">
@@ -11000,7 +11000,7 @@
         </p:nvSpPr>
         <p:spPr>
           <a:xfrm>
-            <a:off x="548640" y="5797296"/>
+            <a:off x="548640" y="5724144"/>
             <a:ext cx="1097280" cy="246888"/>
           </a:xfrm>
           <a:prstGeom prst="rect">
@@ -11042,7 +11042,7 @@
         </p:nvSpPr>
         <p:spPr>
           <a:xfrm>
-            <a:off x="1645920" y="5797296"/>
+            <a:off x="1645920" y="5724144"/>
             <a:ext cx="2377440" cy="246888"/>
           </a:xfrm>
           <a:prstGeom prst="rect">
@@ -11070,7 +11070,7 @@
                 <a:ea typeface="Calibri" pitchFamily="34" charset="-122"/>
                 <a:cs typeface="Calibri" pitchFamily="34" charset="-120"/>
               </a:rPr>
-              <a:t>400+ and recruiting</a:t>
+              <a:t>458 and recruiting</a:t>
             </a:r>
             <a:endParaRPr lang="en-US" sz="1100" dirty="0"/>
           </a:p>
@@ -11084,7 +11084,7 @@
         </p:nvSpPr>
         <p:spPr>
           <a:xfrm>
-            <a:off x="548640" y="6044184"/>
+            <a:off x="548640" y="5971032"/>
             <a:ext cx="1097280" cy="246888"/>
           </a:xfrm>
           <a:prstGeom prst="rect">
@@ -11112,6 +11112,90 @@
                 <a:ea typeface="Calibri" pitchFamily="34" charset="-122"/>
                 <a:cs typeface="Calibri" pitchFamily="34" charset="-120"/>
               </a:rPr>
+              <a:t>Reach</a:t>
+            </a:r>
+            <a:endParaRPr lang="en-US" sz="1100" dirty="0"/>
+          </a:p>
+        </p:txBody>
+      </p:sp>
+      <p:sp>
+        <p:nvSpPr>
+          <p:cNvPr id="13" name="Text 9"/>
+          <p:cNvSpPr txBox="1"/>
+          <p:nvPr/>
+        </p:nvSpPr>
+        <p:spPr>
+          <a:xfrm>
+            <a:off x="1645920" y="5971032"/>
+            <a:ext cx="2377440" cy="246888"/>
+          </a:xfrm>
+          <a:prstGeom prst="rect">
+            <a:avLst/>
+          </a:prstGeom>
+          <a:noFill/>
+          <a:ln/>
+        </p:spPr>
+        <p:txBody>
+          <a:bodyPr wrap="square" lIns="0" tIns="0" rIns="0" bIns="0" rtlCol="0" anchor="t"/>
+          <a:lstStyle/>
+          <a:p>
+            <a:pPr algn="l" indent="0" marL="0">
+              <a:lnSpc>
+                <a:spcPct val="110000"/>
+              </a:lnSpc>
+              <a:buNone/>
+            </a:pPr>
+            <a:r>
+              <a:rPr lang="en-US" sz="1100" dirty="0">
+                <a:solidFill>
+                  <a:srgbClr val="B3A995"/>
+                </a:solidFill>
+                <a:latin typeface="Calibri" pitchFamily="34" charset="0"/>
+                <a:ea typeface="Calibri" pitchFamily="34" charset="-122"/>
+                <a:cs typeface="Calibri" pitchFamily="34" charset="-120"/>
+              </a:rPr>
+              <a:t>42 states, 7 DX countries</a:t>
+            </a:r>
+            <a:endParaRPr lang="en-US" sz="1100" dirty="0"/>
+          </a:p>
+        </p:txBody>
+      </p:sp>
+      <p:sp>
+        <p:nvSpPr>
+          <p:cNvPr id="14" name="Text 10"/>
+          <p:cNvSpPr txBox="1"/>
+          <p:nvPr/>
+        </p:nvSpPr>
+        <p:spPr>
+          <a:xfrm>
+            <a:off x="548640" y="6217920"/>
+            <a:ext cx="1097280" cy="246888"/>
+          </a:xfrm>
+          <a:prstGeom prst="rect">
+            <a:avLst/>
+          </a:prstGeom>
+          <a:noFill/>
+          <a:ln/>
+        </p:spPr>
+        <p:txBody>
+          <a:bodyPr wrap="square" lIns="0" tIns="0" rIns="0" bIns="0" rtlCol="0" anchor="t"/>
+          <a:lstStyle/>
+          <a:p>
+            <a:pPr algn="l" indent="0" marL="0">
+              <a:lnSpc>
+                <a:spcPct val="110000"/>
+              </a:lnSpc>
+              <a:buNone/>
+            </a:pPr>
+            <a:r>
+              <a:rPr lang="en-US" sz="1100" b="1" dirty="0">
+                <a:solidFill>
+                  <a:srgbClr val="D4AF37"/>
+                </a:solidFill>
+                <a:latin typeface="Calibri" pitchFamily="34" charset="0"/>
+                <a:ea typeface="Calibri" pitchFamily="34" charset="-122"/>
+                <a:cs typeface="Calibri" pitchFamily="34" charset="-120"/>
+              </a:rPr>
               <a:t>Mode</a:t>
             </a:r>
             <a:endParaRPr lang="en-US" sz="1100" dirty="0"/>
@@ -11120,13 +11204,13 @@
       </p:sp>
       <p:sp>
         <p:nvSpPr>
-          <p:cNvPr id="13" name="Text 9"/>
-          <p:cNvSpPr txBox="1"/>
-          <p:nvPr/>
-        </p:nvSpPr>
-        <p:spPr>
-          <a:xfrm>
-            <a:off x="1645920" y="6044184"/>
+          <p:cNvPr id="15" name="Text 11"/>
+          <p:cNvSpPr txBox="1"/>
+          <p:nvPr/>
+        </p:nvSpPr>
+        <p:spPr>
+          <a:xfrm>
+            <a:off x="1645920" y="6217920"/>
             <a:ext cx="2377440" cy="246888"/>
           </a:xfrm>
           <a:prstGeom prst="rect">
@@ -11162,7 +11246,7 @@
       </p:sp>
       <p:sp>
         <p:nvSpPr>
-          <p:cNvPr id="14" name="Shape 10"/>
+          <p:cNvPr id="16" name="Shape 12"/>
           <p:cNvSpPr/>
           <p:nvPr/>
         </p:nvSpPr>
@@ -11189,7 +11273,7 @@
       </p:sp>
       <p:sp>
         <p:nvSpPr>
-          <p:cNvPr id="15" name="Shape 11"/>
+          <p:cNvPr id="17" name="Shape 13"/>
           <p:cNvSpPr/>
           <p:nvPr/>
         </p:nvSpPr>
@@ -11214,7 +11298,7 @@
       </p:sp>
       <p:pic>
         <p:nvPicPr>
-          <p:cNvPr id="16" name="Image 1" descr="preencoded.png">    </p:cNvPr>
+          <p:cNvPr id="18" name="Image 1" descr="preencoded.png">    </p:cNvPr>
           <p:cNvPicPr>
             <a:picLocks noChangeAspect="1"/>
           </p:cNvPicPr>
@@ -11238,7 +11322,7 @@
       </p:pic>
       <p:sp>
         <p:nvSpPr>
-          <p:cNvPr id="17" name="Text 12"/>
+          <p:cNvPr id="19" name="Text 14"/>
           <p:cNvSpPr txBox="1"/>
           <p:nvPr/>
         </p:nvSpPr>
@@ -11277,7 +11361,7 @@
       </p:sp>
       <p:sp>
         <p:nvSpPr>
-          <p:cNvPr id="18" name="Text 13"/>
+          <p:cNvPr id="20" name="Text 15"/>
           <p:cNvSpPr txBox="1"/>
           <p:nvPr/>
         </p:nvSpPr>
@@ -11319,7 +11403,7 @@
       </p:sp>
       <p:sp>
         <p:nvSpPr>
-          <p:cNvPr id="19" name="Text 14"/>
+          <p:cNvPr id="21" name="Text 16"/>
           <p:cNvSpPr txBox="1"/>
           <p:nvPr/>
         </p:nvSpPr>
@@ -11361,7 +11445,7 @@
       </p:sp>
       <p:sp>
         <p:nvSpPr>
-          <p:cNvPr id="20" name="Text 15"/>
+          <p:cNvPr id="22" name="Text 17"/>
           <p:cNvSpPr txBox="1"/>
           <p:nvPr/>
         </p:nvSpPr>
@@ -11403,7 +11487,7 @@
       </p:sp>
       <p:sp>
         <p:nvSpPr>
-          <p:cNvPr id="21" name="Text 16"/>
+          <p:cNvPr id="23" name="Text 18"/>
           <p:cNvSpPr txBox="1"/>
           <p:nvPr/>
         </p:nvSpPr>
@@ -11445,7 +11529,7 @@
       </p:sp>
       <p:sp>
         <p:nvSpPr>
-          <p:cNvPr id="22" name="Text 17"/>
+          <p:cNvPr id="24" name="Text 19"/>
           <p:cNvSpPr txBox="1"/>
           <p:nvPr/>
         </p:nvSpPr>
@@ -11487,7 +11571,7 @@
       </p:sp>
       <p:sp>
         <p:nvSpPr>
-          <p:cNvPr id="23" name="Text 18"/>
+          <p:cNvPr id="25" name="Text 20"/>
           <p:cNvSpPr txBox="1"/>
           <p:nvPr/>
         </p:nvSpPr>
@@ -11529,7 +11613,7 @@
       </p:sp>
       <p:sp>
         <p:nvSpPr>
-          <p:cNvPr id="24" name="Shape 19"/>
+          <p:cNvPr id="26" name="Shape 21"/>
           <p:cNvSpPr/>
           <p:nvPr/>
         </p:nvSpPr>
@@ -11556,7 +11640,7 @@
       </p:sp>
       <p:sp>
         <p:nvSpPr>
-          <p:cNvPr id="25" name="Shape 20"/>
+          <p:cNvPr id="27" name="Shape 22"/>
           <p:cNvSpPr/>
           <p:nvPr/>
         </p:nvSpPr>
@@ -11581,7 +11665,7 @@
       </p:sp>
       <p:pic>
         <p:nvPicPr>
-          <p:cNvPr id="26" name="Image 2" descr="preencoded.png">    </p:cNvPr>
+          <p:cNvPr id="28" name="Image 2" descr="preencoded.png">    </p:cNvPr>
           <p:cNvPicPr>
             <a:picLocks noChangeAspect="1"/>
           </p:cNvPicPr>
@@ -11605,7 +11689,7 @@
       </p:pic>
       <p:sp>
         <p:nvSpPr>
-          <p:cNvPr id="27" name="Text 21"/>
+          <p:cNvPr id="29" name="Text 23"/>
           <p:cNvSpPr txBox="1"/>
           <p:nvPr/>
         </p:nvSpPr>
@@ -11644,7 +11728,7 @@
       </p:sp>
       <p:sp>
         <p:nvSpPr>
-          <p:cNvPr id="28" name="Shape 22"/>
+          <p:cNvPr id="30" name="Shape 24"/>
           <p:cNvSpPr/>
           <p:nvPr/>
         </p:nvSpPr>
@@ -11669,7 +11753,7 @@
       </p:sp>
       <p:sp>
         <p:nvSpPr>
-          <p:cNvPr id="29" name="Text 23"/>
+          <p:cNvPr id="31" name="Text 25"/>
           <p:cNvSpPr txBox="1"/>
           <p:nvPr/>
         </p:nvSpPr>
@@ -11708,7 +11792,7 @@
       </p:sp>
       <p:sp>
         <p:nvSpPr>
-          <p:cNvPr id="30" name="Text 24"/>
+          <p:cNvPr id="32" name="Text 26"/>
           <p:cNvSpPr txBox="1"/>
           <p:nvPr/>
         </p:nvSpPr>
@@ -11750,7 +11834,7 @@
       </p:sp>
       <p:sp>
         <p:nvSpPr>
-          <p:cNvPr id="31" name="Text 25"/>
+          <p:cNvPr id="33" name="Text 27"/>
           <p:cNvSpPr txBox="1"/>
           <p:nvPr/>
         </p:nvSpPr>
@@ -11792,7 +11876,7 @@
       </p:sp>
       <p:sp>
         <p:nvSpPr>
-          <p:cNvPr id="32" name="Shape 26"/>
+          <p:cNvPr id="34" name="Shape 28"/>
           <p:cNvSpPr/>
           <p:nvPr/>
         </p:nvSpPr>
@@ -11817,7 +11901,7 @@
       </p:sp>
       <p:sp>
         <p:nvSpPr>
-          <p:cNvPr id="33" name="Text 27"/>
+          <p:cNvPr id="35" name="Text 29"/>
           <p:cNvSpPr txBox="1"/>
           <p:nvPr/>
         </p:nvSpPr>
@@ -11856,7 +11940,7 @@
       </p:sp>
       <p:sp>
         <p:nvSpPr>
-          <p:cNvPr id="34" name="Text 28"/>
+          <p:cNvPr id="36" name="Text 30"/>
           <p:cNvSpPr txBox="1"/>
           <p:nvPr/>
         </p:nvSpPr>
@@ -11898,7 +11982,7 @@
       </p:sp>
       <p:sp>
         <p:nvSpPr>
-          <p:cNvPr id="35" name="Text 29"/>
+          <p:cNvPr id="37" name="Text 31"/>
           <p:cNvSpPr txBox="1"/>
           <p:nvPr/>
         </p:nvSpPr>
@@ -11940,7 +12024,7 @@
       </p:sp>
       <p:sp>
         <p:nvSpPr>
-          <p:cNvPr id="36" name="Shape 30"/>
+          <p:cNvPr id="38" name="Shape 32"/>
           <p:cNvSpPr/>
           <p:nvPr/>
         </p:nvSpPr>
@@ -11965,7 +12049,7 @@
       </p:sp>
       <p:sp>
         <p:nvSpPr>
-          <p:cNvPr id="37" name="Text 31"/>
+          <p:cNvPr id="39" name="Text 33"/>
           <p:cNvSpPr txBox="1"/>
           <p:nvPr/>
         </p:nvSpPr>
@@ -12004,7 +12088,7 @@
       </p:sp>
       <p:sp>
         <p:nvSpPr>
-          <p:cNvPr id="38" name="Text 32"/>
+          <p:cNvPr id="40" name="Text 34"/>
           <p:cNvSpPr txBox="1"/>
           <p:nvPr/>
         </p:nvSpPr>
@@ -12046,7 +12130,7 @@
       </p:sp>
       <p:sp>
         <p:nvSpPr>
-          <p:cNvPr id="39" name="Text 33"/>
+          <p:cNvPr id="41" name="Text 35"/>
           <p:cNvSpPr txBox="1"/>
           <p:nvPr/>
         </p:nvSpPr>
@@ -12088,7 +12172,7 @@
       </p:sp>
       <p:sp>
         <p:nvSpPr>
-          <p:cNvPr id="40" name="Text 34"/>
+          <p:cNvPr id="42" name="Text 36"/>
           <p:cNvSpPr txBox="1"/>
           <p:nvPr/>
         </p:nvSpPr>
@@ -12881,7 +12965,7 @@
         </p:nvSpPr>
         <p:spPr>
           <a:xfrm>
-            <a:off x="6507328" y="3520440"/>
+            <a:off x="6507328" y="3419856"/>
             <a:ext cx="4861408" cy="320040"/>
           </a:xfrm>
           <a:prstGeom prst="rect">
@@ -12923,7 +13007,7 @@
         </p:nvSpPr>
         <p:spPr>
           <a:xfrm>
-            <a:off x="6507328" y="3840480"/>
+            <a:off x="6507328" y="3739896"/>
             <a:ext cx="4861408" cy="320040"/>
           </a:xfrm>
           <a:prstGeom prst="rect">
@@ -12962,7 +13046,7 @@
         </p:nvSpPr>
         <p:spPr>
           <a:xfrm>
-            <a:off x="6507328" y="4297680"/>
+            <a:off x="6507328" y="4096512"/>
             <a:ext cx="4861408" cy="320040"/>
           </a:xfrm>
           <a:prstGeom prst="rect">
@@ -12990,7 +13074,7 @@
                 <a:ea typeface="Calibri" pitchFamily="34" charset="-122"/>
                 <a:cs typeface="Calibri" pitchFamily="34" charset="-120"/>
               </a:rPr>
-              <a:t>Recruit form and downline tree</a:t>
+              <a:t>Recruit form, downline tree, nearby finder</a:t>
             </a:r>
             <a:endParaRPr lang="en-US" sz="1400" dirty="0"/>
           </a:p>
@@ -13004,7 +13088,7 @@
         </p:nvSpPr>
         <p:spPr>
           <a:xfrm>
-            <a:off x="6507328" y="4617720"/>
+            <a:off x="6507328" y="4416552"/>
             <a:ext cx="4861408" cy="320040"/>
           </a:xfrm>
           <a:prstGeom prst="rect">
@@ -13029,7 +13113,7 @@
                 <a:ea typeface="Courier New" pitchFamily="34" charset="-122"/>
                 <a:cs typeface="Courier New" pitchFamily="34" charset="-120"/>
               </a:rPr>
-              <a:t>bkg.club/recruit.html  ·  bkg.club/tree.html</a:t>
+              <a:t>bkg.club/recruit.html  ·  /tree.html  ·  /nearby.html</a:t>
             </a:r>
             <a:endParaRPr lang="en-US" sz="1200" dirty="0"/>
           </a:p>
@@ -13043,7 +13127,7 @@
         </p:nvSpPr>
         <p:spPr>
           <a:xfrm>
-            <a:off x="6507328" y="5074920"/>
+            <a:off x="6507328" y="4773168"/>
             <a:ext cx="4861408" cy="320040"/>
           </a:xfrm>
           <a:prstGeom prst="rect">
@@ -13085,7 +13169,7 @@
         </p:nvSpPr>
         <p:spPr>
           <a:xfrm>
-            <a:off x="6507328" y="5394960"/>
+            <a:off x="6507328" y="5093208"/>
             <a:ext cx="4861408" cy="320040"/>
           </a:xfrm>
           <a:prstGeom prst="rect">
@@ -13119,6 +13203,87 @@
       <p:sp>
         <p:nvSpPr>
           <p:cNvPr id="29" name="Text 24"/>
+          <p:cNvSpPr txBox="1"/>
+          <p:nvPr/>
+        </p:nvSpPr>
+        <p:spPr>
+          <a:xfrm>
+            <a:off x="6507328" y="5449824"/>
+            <a:ext cx="4861408" cy="320040"/>
+          </a:xfrm>
+          <a:prstGeom prst="rect">
+            <a:avLst/>
+          </a:prstGeom>
+          <a:noFill/>
+          <a:ln/>
+        </p:spPr>
+        <p:txBody>
+          <a:bodyPr wrap="square" lIns="0" tIns="0" rIns="0" bIns="0" rtlCol="0" anchor="t"/>
+          <a:lstStyle/>
+          <a:p>
+            <a:pPr algn="l" indent="0" marL="0">
+              <a:lnSpc>
+                <a:spcPct val="110000"/>
+              </a:lnSpc>
+              <a:buNone/>
+            </a:pPr>
+            <a:r>
+              <a:rPr lang="en-US" sz="1400" b="1" dirty="0">
+                <a:solidFill>
+                  <a:srgbClr val="F2EBDD"/>
+                </a:solidFill>
+                <a:latin typeface="Calibri" pitchFamily="34" charset="0"/>
+                <a:ea typeface="Calibri" pitchFamily="34" charset="-122"/>
+                <a:cs typeface="Calibri" pitchFamily="34" charset="-120"/>
+              </a:rPr>
+              <a:t>BKG intro video (YouTube short)</a:t>
+            </a:r>
+            <a:endParaRPr lang="en-US" sz="1400" dirty="0"/>
+          </a:p>
+        </p:txBody>
+      </p:sp>
+      <p:sp>
+        <p:nvSpPr>
+          <p:cNvPr id="30" name="Text 25"/>
+          <p:cNvSpPr txBox="1"/>
+          <p:nvPr/>
+        </p:nvSpPr>
+        <p:spPr>
+          <a:xfrm>
+            <a:off x="6507328" y="5769864"/>
+            <a:ext cx="4861408" cy="320040"/>
+          </a:xfrm>
+          <a:prstGeom prst="rect">
+            <a:avLst/>
+          </a:prstGeom>
+          <a:noFill/>
+          <a:ln/>
+        </p:spPr>
+        <p:txBody>
+          <a:bodyPr wrap="square" lIns="0" tIns="0" rIns="0" bIns="0" rtlCol="0" anchor="t"/>
+          <a:lstStyle/>
+          <a:p>
+            <a:pPr indent="0" marL="0">
+              <a:buNone/>
+            </a:pPr>
+            <a:r>
+              <a:rPr lang="en-US" sz="1200" dirty="0">
+                <a:solidFill>
+                  <a:srgbClr val="D4AF37"/>
+                </a:solidFill>
+                <a:latin typeface="Courier New" pitchFamily="34" charset="0"/>
+                <a:ea typeface="Courier New" pitchFamily="34" charset="-122"/>
+                <a:cs typeface="Courier New" pitchFamily="34" charset="-120"/>
+              </a:rPr>
+              <a:t>youtube.com/shorts/2ZWex-8fG6M</a:t>
+            </a:r>
+            <a:endParaRPr lang="en-US" sz="1200" dirty="0"/>
+          </a:p>
+        </p:txBody>
+      </p:sp>
+      <p:sp>
+        <p:nvSpPr>
+          <p:cNvPr id="31" name="Text 26"/>
           <p:cNvSpPr txBox="1"/>
           <p:nvPr/>
         </p:nvSpPr>

</xml_diff>

<commit_message>
Add an Another Morse Trainer slide with a Discord QR code
Inserted before the closing links slide: what the app does, where to get
it, and a QR code for the AMT Discord, sourced from the app and site repos.

Co-Authored-By: Claude Fable 5.1 <noreply@anthropic.com>
Claude-Session: https://claude.ai/code/session_01KDZck9uBeSHBv7szzYQxJN
</commit_message>
<xml_diff>
--- a/docs/talks/quansheng-2m-cw/quansheng-2m-cw.pptx
+++ b/docs/talks/quansheng-2m-cw/quansheng-2m-cw.pptx
@@ -24,9 +24,10 @@
     <p:sldId id="272" r:id="rId18"/>
     <p:sldId id="273" r:id="rId19"/>
     <p:sldId id="274" r:id="rId20"/>
+    <p:sldId id="275" r:id="rId21"/>
   </p:sldIdLst>
   <p:notesMasterIdLst>
-    <p:notesMasterId r:id="rId21"/>
+    <p:notesMasterId r:id="rId22"/>
   </p:notesMasterIdLst>
   <p:sldSz cx="12192000" cy="6858000"/>
   <p:notesSz cx="6858000" cy="12192000"/>
@@ -1400,7 +1401,7 @@
           <a:p>
             <a:r>
               <a:rPr lang="en-US" dirty="0"/>
-              <a:t>Leave this up during questions. The docs site has the full-resolution rework photos and the menu reference; the releases page has the firmware and the CHIRP module; uvtools2 is the flasher. bkg.club/clubs.html is the version of this talk you can read out loud at a board meeting.</a:t>
+              <a:t>This one is yours, so say so. Another Morse Trainer is the app you wrote because you spent as much time switching between practice tools as practicing. Koch method at 33 WPM from day one, every answer timed so it drills what is still slow, a guided Journey with an unlock map, confusion drills, hands-free practice for the car, sending on a touch key or a MIDI key or a Vail adapter with live decode, a mic decoder for the rig, pileups and contests, and a word-a-day puzzle. Free, GPL-3, no ads, no subscriptions, same feature set on both phones. iPhone and iPad are in open beta on TestFlight; Android is closed testing and the Discord is where invites go out, so point at the QR code. The vendored CW decoder is Jay Vana's, who is on the BKG roster as W6JY. As of September 11 the builds were iOS 1.3.0 and Android 1.15.0.</a:t>
             </a:r>
             <a:endParaRPr lang="en-US" dirty="0"/>
           </a:p>
@@ -1512,6 +1513,94 @@
             <a:fld id="{F7021451-1387-4CA6-816F-3879F97B5CBC}" type="slidenum">
               <a:rPr lang="en-US"/>
               <a:t>2</a:t>
+            </a:fld>
+            <a:endParaRPr lang="en-US"/>
+          </a:p>
+        </p:txBody>
+      </p:sp>
+    </p:spTree>
+    <p:extLst>
+      <p:ext uri="{BB962C8B-B14F-4D97-AF65-F5344CB8AC3E}">
+        <p14:creationId xmlns:p14="http://schemas.microsoft.com/office/powerpoint/2010/main" val="1024086991"/>
+      </p:ext>
+    </p:extLst>
+  </p:cSld>
+  <p:clrMapOvr>
+    <a:masterClrMapping/>
+  </p:clrMapOvr>
+</p:notes>
+</file>
+
+<file path=ppt/notesSlides/notesSlide20.xml><?xml version="1.0" encoding="utf-8"?>
+<p:notes xmlns:a="http://schemas.openxmlformats.org/drawingml/2006/main" xmlns:r="http://schemas.openxmlformats.org/officeDocument/2006/relationships" xmlns:p="http://schemas.openxmlformats.org/presentationml/2006/main">
+  <p:cSld>
+    <p:spTree>
+      <p:nvGrpSpPr>
+        <p:cNvPr id="1" name=""/>
+        <p:cNvGrpSpPr/>
+        <p:nvPr/>
+      </p:nvGrpSpPr>
+      <p:grpSpPr>
+        <a:xfrm>
+          <a:off x="0" y="0"/>
+          <a:ext cx="0" cy="0"/>
+          <a:chOff x="0" y="0"/>
+          <a:chExt cx="0" cy="0"/>
+        </a:xfrm>
+      </p:grpSpPr>
+      <p:sp>
+        <p:nvSpPr>
+          <p:cNvPr id="2" name="Slide Image Placeholder 1"/>
+          <p:cNvSpPr>
+            <a:spLocks noGrp="1" noRot="1" noChangeAspect="1"/>
+          </p:cNvSpPr>
+          <p:nvPr>
+            <p:ph type="sldImg"/>
+          </p:nvPr>
+        </p:nvSpPr>
+        <p:spPr/>
+      </p:sp>
+      <p:sp>
+        <p:nvSpPr>
+          <p:cNvPr id="3" name="Notes Placeholder 2"/>
+          <p:cNvSpPr>
+            <a:spLocks noGrp="1"/>
+          </p:cNvSpPr>
+          <p:nvPr>
+            <p:ph type="body" idx="1"/>
+          </p:nvPr>
+        </p:nvSpPr>
+        <p:spPr/>
+        <p:txBody>
+          <a:bodyPr/>
+          <a:lstStyle/>
+          <a:p>
+            <a:r>
+              <a:rPr lang="en-US" dirty="0"/>
+              <a:t>Leave this up during questions. The docs site has the full-resolution rework photos and the menu reference; the releases page has the firmware and the CHIRP module; uvtools2 is the flasher. bkg.club/clubs.html is the version of this talk you can read out loud at a board meeting.</a:t>
+            </a:r>
+            <a:endParaRPr lang="en-US" dirty="0"/>
+          </a:p>
+        </p:txBody>
+      </p:sp>
+      <p:sp>
+        <p:nvSpPr>
+          <p:cNvPr id="4" name="Slide Number Placeholder 3"/>
+          <p:cNvSpPr>
+            <a:spLocks noGrp="1"/>
+          </p:cNvSpPr>
+          <p:nvPr>
+            <p:ph type="sldNum" sz="quarter" idx="10"/>
+          </p:nvPr>
+        </p:nvSpPr>
+        <p:spPr/>
+        <p:txBody>
+          <a:bodyPr/>
+          <a:lstStyle/>
+          <a:p>
+            <a:fld id="{F7021451-1387-4CA6-816F-3879F97B5CBC}" type="slidenum">
+              <a:rPr lang="en-US"/>
+              <a:t>20</a:t>
             </a:fld>
             <a:endParaRPr lang="en-US"/>
           </a:p>
@@ -12277,7 +12366,7 @@
                 <a:ea typeface="Cambria" pitchFamily="34" charset="-122"/>
                 <a:cs typeface="Cambria" pitchFamily="34" charset="-120"/>
               </a:rPr>
-              <a:t>Links, credits, 73</a:t>
+              <a:t>Another Morse Trainer</a:t>
             </a:r>
             <a:endParaRPr lang="en-US" sz="3600" dirty="0"/>
           </a:p>
@@ -12316,7 +12405,7 @@
                 <a:ea typeface="Calibri" pitchFamily="34" charset="-122"/>
                 <a:cs typeface="Calibri" pitchFamily="34" charset="-120"/>
               </a:rPr>
-              <a:t>Leave this slide up. Everything tonight came from these.</a:t>
+              <a:t>Learn Morse. Hear Progress. Free and open source, on iPhone and Android.</a:t>
             </a:r>
             <a:endParaRPr lang="en-US" sz="1600" dirty="0"/>
           </a:p>
@@ -12331,11 +12420,11 @@
         <p:spPr>
           <a:xfrm>
             <a:off x="548640" y="1828800"/>
-            <a:ext cx="5410048" cy="4434840"/>
+            <a:ext cx="3200400" cy="4434840"/>
           </a:xfrm>
           <a:prstGeom prst="roundRect">
             <a:avLst>
-              <a:gd name="adj" fmla="val 2474"/>
+              <a:gd name="adj" fmla="val 3429"/>
             </a:avLst>
           </a:prstGeom>
           <a:solidFill>
@@ -12349,15 +12438,276 @@
           </a:ln>
         </p:spPr>
       </p:sp>
-      <p:sp>
-        <p:nvSpPr>
-          <p:cNvPr id="6" name="Shape 3"/>
+      <p:pic>
+        <p:nvPicPr>
+          <p:cNvPr id="6" name="Image 0" descr="/tmp/claude-0/-home-user-bkg-club/dd98b25f-744f-5b52-bca4-d25dd18876d9/scratchpad/img/logo-stacked.png">    </p:cNvPr>
+          <p:cNvPicPr>
+            <a:picLocks noChangeAspect="1"/>
+          </p:cNvPicPr>
+          <p:nvPr/>
+        </p:nvPicPr>
+        <p:blipFill>
+          <a:blip r:embed="rId1"/>
+          <a:stretch>
+            <a:fillRect/>
+          </a:stretch>
+        </p:blipFill>
+        <p:spPr>
+          <a:xfrm>
+            <a:off x="1417320" y="2011680"/>
+            <a:ext cx="1463040" cy="2029968"/>
+          </a:xfrm>
+          <a:prstGeom prst="rect">
+            <a:avLst/>
+          </a:prstGeom>
+        </p:spPr>
+      </p:pic>
+      <p:sp>
+        <p:nvSpPr>
+          <p:cNvPr id="7" name="Text 3"/>
+          <p:cNvSpPr txBox="1"/>
+          <p:nvPr/>
+        </p:nvSpPr>
+        <p:spPr>
+          <a:xfrm>
+            <a:off x="822960" y="4206240"/>
+            <a:ext cx="2651760" cy="822960"/>
+          </a:xfrm>
+          <a:prstGeom prst="rect">
+            <a:avLst/>
+          </a:prstGeom>
+          <a:noFill/>
+          <a:ln/>
+        </p:spPr>
+        <p:txBody>
+          <a:bodyPr wrap="square" lIns="0" tIns="0" rIns="0" bIns="0" rtlCol="0" anchor="t"/>
+          <a:lstStyle/>
+          <a:p>
+            <a:pPr algn="ctr" indent="0" marL="0">
+              <a:lnSpc>
+                <a:spcPct val="110000"/>
+              </a:lnSpc>
+              <a:buNone/>
+            </a:pPr>
+            <a:r>
+              <a:rPr lang="en-US" sz="1250" dirty="0">
+                <a:solidFill>
+                  <a:srgbClr val="F2EBDD"/>
+                </a:solidFill>
+                <a:latin typeface="Calibri" pitchFamily="34" charset="0"/>
+                <a:ea typeface="Calibri" pitchFamily="34" charset="-122"/>
+                <a:cs typeface="Calibri" pitchFamily="34" charset="-120"/>
+              </a:rPr>
+              <a:t>Free and open source (GPL-3). No ads, no subscriptions, same features on both phones.</a:t>
+            </a:r>
+            <a:endParaRPr lang="en-US" sz="1250" dirty="0"/>
+          </a:p>
+        </p:txBody>
+      </p:sp>
+      <p:sp>
+        <p:nvSpPr>
+          <p:cNvPr id="8" name="Text 4"/>
+          <p:cNvSpPr txBox="1"/>
+          <p:nvPr/>
+        </p:nvSpPr>
+        <p:spPr>
+          <a:xfrm>
+            <a:off x="822960" y="5074920"/>
+            <a:ext cx="2651760" cy="274320"/>
+          </a:xfrm>
+          <a:prstGeom prst="rect">
+            <a:avLst/>
+          </a:prstGeom>
+          <a:noFill/>
+          <a:ln/>
+        </p:spPr>
+        <p:txBody>
+          <a:bodyPr wrap="square" lIns="0" tIns="0" rIns="0" bIns="0" rtlCol="0" anchor="t"/>
+          <a:lstStyle/>
+          <a:p>
+            <a:pPr algn="ctr" indent="0" marL="0">
+              <a:lnSpc>
+                <a:spcPct val="110000"/>
+              </a:lnSpc>
+              <a:buNone/>
+            </a:pPr>
+            <a:r>
+              <a:rPr lang="en-US" sz="1250" b="1" dirty="0">
+                <a:solidFill>
+                  <a:srgbClr val="D4AF37"/>
+                </a:solidFill>
+                <a:latin typeface="Calibri" pitchFamily="34" charset="0"/>
+                <a:ea typeface="Calibri" pitchFamily="34" charset="-122"/>
+                <a:cs typeface="Calibri" pitchFamily="34" charset="-120"/>
+              </a:rPr>
+              <a:t>iPhone &amp; iPad</a:t>
+            </a:r>
+            <a:endParaRPr lang="en-US" sz="1250" dirty="0"/>
+          </a:p>
+        </p:txBody>
+      </p:sp>
+      <p:sp>
+        <p:nvSpPr>
+          <p:cNvPr id="9" name="Text 5"/>
+          <p:cNvSpPr txBox="1"/>
+          <p:nvPr/>
+        </p:nvSpPr>
+        <p:spPr>
+          <a:xfrm>
+            <a:off x="822960" y="5321808"/>
+            <a:ext cx="2651760" cy="274320"/>
+          </a:xfrm>
+          <a:prstGeom prst="rect">
+            <a:avLst/>
+          </a:prstGeom>
+          <a:noFill/>
+          <a:ln/>
+        </p:spPr>
+        <p:txBody>
+          <a:bodyPr wrap="square" lIns="0" tIns="0" rIns="0" bIns="0" rtlCol="0" anchor="t"/>
+          <a:lstStyle/>
+          <a:p>
+            <a:pPr algn="ctr" indent="0" marL="0">
+              <a:lnSpc>
+                <a:spcPct val="110000"/>
+              </a:lnSpc>
+              <a:buNone/>
+            </a:pPr>
+            <a:r>
+              <a:rPr lang="en-US" sz="1200" dirty="0">
+                <a:solidFill>
+                  <a:srgbClr val="B3A995"/>
+                </a:solidFill>
+                <a:latin typeface="Calibri" pitchFamily="34" charset="0"/>
+                <a:ea typeface="Calibri" pitchFamily="34" charset="-122"/>
+                <a:cs typeface="Calibri" pitchFamily="34" charset="-120"/>
+              </a:rPr>
+              <a:t>Open beta on TestFlight</a:t>
+            </a:r>
+            <a:endParaRPr lang="en-US" sz="1200" dirty="0"/>
+          </a:p>
+        </p:txBody>
+      </p:sp>
+      <p:sp>
+        <p:nvSpPr>
+          <p:cNvPr id="10" name="Text 6"/>
+          <p:cNvSpPr txBox="1"/>
+          <p:nvPr/>
+        </p:nvSpPr>
+        <p:spPr>
+          <a:xfrm>
+            <a:off x="822960" y="5623560"/>
+            <a:ext cx="2651760" cy="274320"/>
+          </a:xfrm>
+          <a:prstGeom prst="rect">
+            <a:avLst/>
+          </a:prstGeom>
+          <a:noFill/>
+          <a:ln/>
+        </p:spPr>
+        <p:txBody>
+          <a:bodyPr wrap="square" lIns="0" tIns="0" rIns="0" bIns="0" rtlCol="0" anchor="t"/>
+          <a:lstStyle/>
+          <a:p>
+            <a:pPr algn="ctr" indent="0" marL="0">
+              <a:lnSpc>
+                <a:spcPct val="110000"/>
+              </a:lnSpc>
+              <a:buNone/>
+            </a:pPr>
+            <a:r>
+              <a:rPr lang="en-US" sz="1250" b="1" dirty="0">
+                <a:solidFill>
+                  <a:srgbClr val="D4AF37"/>
+                </a:solidFill>
+                <a:latin typeface="Calibri" pitchFamily="34" charset="0"/>
+                <a:ea typeface="Calibri" pitchFamily="34" charset="-122"/>
+                <a:cs typeface="Calibri" pitchFamily="34" charset="-120"/>
+              </a:rPr>
+              <a:t>Android</a:t>
+            </a:r>
+            <a:endParaRPr lang="en-US" sz="1250" dirty="0"/>
+          </a:p>
+        </p:txBody>
+      </p:sp>
+      <p:sp>
+        <p:nvSpPr>
+          <p:cNvPr id="11" name="Text 7"/>
+          <p:cNvSpPr txBox="1"/>
+          <p:nvPr/>
+        </p:nvSpPr>
+        <p:spPr>
+          <a:xfrm>
+            <a:off x="822960" y="5870448"/>
+            <a:ext cx="2651760" cy="274320"/>
+          </a:xfrm>
+          <a:prstGeom prst="rect">
+            <a:avLst/>
+          </a:prstGeom>
+          <a:noFill/>
+          <a:ln/>
+        </p:spPr>
+        <p:txBody>
+          <a:bodyPr wrap="square" lIns="0" tIns="0" rIns="0" bIns="0" rtlCol="0" anchor="t"/>
+          <a:lstStyle/>
+          <a:p>
+            <a:pPr algn="ctr" indent="0" marL="0">
+              <a:lnSpc>
+                <a:spcPct val="110000"/>
+              </a:lnSpc>
+              <a:buNone/>
+            </a:pPr>
+            <a:r>
+              <a:rPr lang="en-US" sz="1200" dirty="0">
+                <a:solidFill>
+                  <a:srgbClr val="B3A995"/>
+                </a:solidFill>
+                <a:latin typeface="Calibri" pitchFamily="34" charset="0"/>
+                <a:ea typeface="Calibri" pitchFamily="34" charset="-122"/>
+                <a:cs typeface="Calibri" pitchFamily="34" charset="-120"/>
+              </a:rPr>
+              <a:t>Closed testing. Ask on the Discord.</a:t>
+            </a:r>
+            <a:endParaRPr lang="en-US" sz="1200" dirty="0"/>
+          </a:p>
+        </p:txBody>
+      </p:sp>
+      <p:sp>
+        <p:nvSpPr>
+          <p:cNvPr id="12" name="Shape 8"/>
           <p:cNvSpPr/>
           <p:nvPr/>
         </p:nvSpPr>
         <p:spPr>
           <a:xfrm>
-            <a:off x="822960" y="2057400"/>
+            <a:off x="4023360" y="1828800"/>
+            <a:ext cx="4343400" cy="4434840"/>
+          </a:xfrm>
+          <a:prstGeom prst="roundRect">
+            <a:avLst>
+              <a:gd name="adj" fmla="val 2526"/>
+            </a:avLst>
+          </a:prstGeom>
+          <a:solidFill>
+            <a:srgbClr val="211D19"/>
+          </a:solidFill>
+          <a:ln w="12700">
+            <a:solidFill>
+              <a:srgbClr val="211D19"/>
+            </a:solidFill>
+            <a:prstDash val="solid"/>
+          </a:ln>
+        </p:spPr>
+      </p:sp>
+      <p:sp>
+        <p:nvSpPr>
+          <p:cNvPr id="13" name="Shape 9"/>
+          <p:cNvSpPr/>
+          <p:nvPr/>
+        </p:nvSpPr>
+        <p:spPr>
+          <a:xfrm>
+            <a:off x="4297680" y="2057400"/>
             <a:ext cx="548640" cy="548640"/>
           </a:xfrm>
           <a:prstGeom prst="ellipse">
@@ -12376,21 +12726,21 @@
       </p:sp>
       <p:pic>
         <p:nvPicPr>
-          <p:cNvPr id="7" name="Image 0" descr="preencoded.png">    </p:cNvPr>
+          <p:cNvPr id="14" name="Image 1" descr="preencoded.png">    </p:cNvPr>
           <p:cNvPicPr>
             <a:picLocks noChangeAspect="1"/>
           </p:cNvPicPr>
           <p:nvPr/>
         </p:nvPicPr>
         <p:blipFill>
-          <a:blip r:embed="rId1"/>
+          <a:blip r:embed="rId2"/>
           <a:stretch>
             <a:fillRect/>
           </a:stretch>
         </p:blipFill>
         <p:spPr>
           <a:xfrm>
-            <a:off x="971093" y="2205533"/>
+            <a:off x="4445813" y="2205533"/>
             <a:ext cx="252374" cy="252374"/>
           </a:xfrm>
           <a:prstGeom prst="rect">
@@ -12400,14 +12750,14 @@
       </p:pic>
       <p:sp>
         <p:nvSpPr>
-          <p:cNvPr id="8" name="Text 4"/>
-          <p:cNvSpPr txBox="1"/>
-          <p:nvPr/>
-        </p:nvSpPr>
-        <p:spPr>
-          <a:xfrm>
-            <a:off x="1508760" y="2148840"/>
-            <a:ext cx="4221328" cy="365760"/>
+          <p:cNvPr id="15" name="Text 10"/>
+          <p:cNvSpPr txBox="1"/>
+          <p:nvPr/>
+        </p:nvSpPr>
+        <p:spPr>
+          <a:xfrm>
+            <a:off x="4983480" y="2148840"/>
+            <a:ext cx="3154680" cy="365760"/>
           </a:xfrm>
           <a:prstGeom prst="rect">
             <a:avLst/>
@@ -12431,7 +12781,7 @@
                 <a:ea typeface="Cambria" pitchFamily="34" charset="-122"/>
                 <a:cs typeface="Cambria" pitchFamily="34" charset="-120"/>
               </a:rPr>
-              <a:t>The radio</a:t>
+              <a:t>What it does</a:t>
             </a:r>
             <a:endParaRPr lang="en-US" sz="2000" dirty="0"/>
           </a:p>
@@ -12439,14 +12789,14 @@
       </p:sp>
       <p:sp>
         <p:nvSpPr>
-          <p:cNvPr id="9" name="Text 5"/>
-          <p:cNvSpPr txBox="1"/>
-          <p:nvPr/>
-        </p:nvSpPr>
-        <p:spPr>
-          <a:xfrm>
-            <a:off x="822960" y="2743200"/>
-            <a:ext cx="4861408" cy="320040"/>
+          <p:cNvPr id="16" name="Text 11"/>
+          <p:cNvSpPr txBox="1"/>
+          <p:nvPr/>
+        </p:nvSpPr>
+        <p:spPr>
+          <a:xfrm>
+            <a:off x="4297680" y="2743200"/>
+            <a:ext cx="3794760" cy="3429000"/>
           </a:xfrm>
           <a:prstGeom prst="rect">
             <a:avLst/>
@@ -12458,14 +12808,18 @@
           <a:bodyPr wrap="square" lIns="0" tIns="0" rIns="0" bIns="0" rtlCol="0" anchor="t"/>
           <a:lstStyle/>
           <a:p>
-            <a:pPr algn="l" indent="0" marL="0">
-              <a:lnSpc>
-                <a:spcPct val="110000"/>
-              </a:lnSpc>
-              <a:buNone/>
-            </a:pPr>
-            <a:r>
-              <a:rPr lang="en-US" sz="1400" b="1" dirty="0">
+            <a:pPr marL="177800" indent="-177800">
+              <a:lnSpc>
+                <a:spcPct val="105000"/>
+              </a:lnSpc>
+              <a:spcAft>
+                <a:spcPts val="400"/>
+              </a:spcAft>
+              <a:buSzPct val="100000"/>
+              <a:buChar char="•"/>
+            </a:pPr>
+            <a:r>
+              <a:rPr lang="en-US" sz="1250" dirty="0">
                 <a:solidFill>
                   <a:srgbClr val="F2EBDD"/>
                 </a:solidFill>
@@ -12473,80 +12827,23 @@
                 <a:ea typeface="Calibri" pitchFamily="34" charset="-122"/>
                 <a:cs typeface="Calibri" pitchFamily="34" charset="-120"/>
               </a:rPr>
-              <a:t>NR7Y CW firmware docs</a:t>
-            </a:r>
-            <a:endParaRPr lang="en-US" sz="1400" dirty="0"/>
-          </a:p>
-        </p:txBody>
-      </p:sp>
-      <p:sp>
-        <p:nvSpPr>
-          <p:cNvPr id="10" name="Text 6"/>
-          <p:cNvSpPr txBox="1"/>
-          <p:nvPr/>
-        </p:nvSpPr>
-        <p:spPr>
-          <a:xfrm>
-            <a:off x="822960" y="3063240"/>
-            <a:ext cx="4861408" cy="320040"/>
-          </a:xfrm>
-          <a:prstGeom prst="rect">
-            <a:avLst/>
-          </a:prstGeom>
-          <a:noFill/>
-          <a:ln/>
-        </p:spPr>
-        <p:txBody>
-          <a:bodyPr wrap="square" lIns="0" tIns="0" rIns="0" bIns="0" rtlCol="0" anchor="t"/>
-          <a:lstStyle/>
-          <a:p>
-            <a:pPr indent="0" marL="0">
-              <a:buNone/>
-            </a:pPr>
-            <a:r>
-              <a:rPr lang="en-US" sz="1200" dirty="0">
-                <a:solidFill>
-                  <a:srgbClr val="D4AF37"/>
-                </a:solidFill>
-                <a:latin typeface="Courier New" pitchFamily="34" charset="0"/>
-                <a:ea typeface="Courier New" pitchFamily="34" charset="-122"/>
-                <a:cs typeface="Courier New" pitchFamily="34" charset="-120"/>
-              </a:rPr>
-              <a:t>briand.github.io/cw-firmware-docs</a:t>
-            </a:r>
-            <a:endParaRPr lang="en-US" sz="1200" dirty="0"/>
-          </a:p>
-        </p:txBody>
-      </p:sp>
-      <p:sp>
-        <p:nvSpPr>
-          <p:cNvPr id="11" name="Text 7"/>
-          <p:cNvSpPr txBox="1"/>
-          <p:nvPr/>
-        </p:nvSpPr>
-        <p:spPr>
-          <a:xfrm>
-            <a:off x="822960" y="3520440"/>
-            <a:ext cx="4861408" cy="320040"/>
-          </a:xfrm>
-          <a:prstGeom prst="rect">
-            <a:avLst/>
-          </a:prstGeom>
-          <a:noFill/>
-          <a:ln/>
-        </p:spPr>
-        <p:txBody>
-          <a:bodyPr wrap="square" lIns="0" tIns="0" rIns="0" bIns="0" rtlCol="0" anchor="t"/>
-          <a:lstStyle/>
-          <a:p>
-            <a:pPr algn="l" indent="0" marL="0">
-              <a:lnSpc>
-                <a:spcPct val="110000"/>
-              </a:lnSpc>
-              <a:buNone/>
-            </a:pPr>
-            <a:r>
-              <a:rPr lang="en-US" sz="1400" b="1" dirty="0">
+              <a:t>Koch method at 33 WPM from day one, with every answer timed so it drills what is still slow.</a:t>
+            </a:r>
+            <a:endParaRPr lang="en-US" sz="1250" dirty="0"/>
+          </a:p>
+          <a:p>
+            <a:pPr marL="177800" indent="-177800">
+              <a:lnSpc>
+                <a:spcPct val="105000"/>
+              </a:lnSpc>
+              <a:spcAft>
+                <a:spcPts val="400"/>
+              </a:spcAft>
+              <a:buSzPct val="100000"/>
+              <a:buChar char="•"/>
+            </a:pPr>
+            <a:r>
+              <a:rPr lang="en-US" sz="1250" dirty="0">
                 <a:solidFill>
                   <a:srgbClr val="F2EBDD"/>
                 </a:solidFill>
@@ -12554,80 +12851,23 @@
                 <a:ea typeface="Calibri" pitchFamily="34" charset="-122"/>
                 <a:cs typeface="Calibri" pitchFamily="34" charset="-120"/>
               </a:rPr>
-              <a:t>Firmware + CHIRP module (Releases)</a:t>
-            </a:r>
-            <a:endParaRPr lang="en-US" sz="1400" dirty="0"/>
-          </a:p>
-        </p:txBody>
-      </p:sp>
-      <p:sp>
-        <p:nvSpPr>
-          <p:cNvPr id="12" name="Text 8"/>
-          <p:cNvSpPr txBox="1"/>
-          <p:nvPr/>
-        </p:nvSpPr>
-        <p:spPr>
-          <a:xfrm>
-            <a:off x="822960" y="3840480"/>
-            <a:ext cx="4861408" cy="320040"/>
-          </a:xfrm>
-          <a:prstGeom prst="rect">
-            <a:avLst/>
-          </a:prstGeom>
-          <a:noFill/>
-          <a:ln/>
-        </p:spPr>
-        <p:txBody>
-          <a:bodyPr wrap="square" lIns="0" tIns="0" rIns="0" bIns="0" rtlCol="0" anchor="t"/>
-          <a:lstStyle/>
-          <a:p>
-            <a:pPr indent="0" marL="0">
-              <a:buNone/>
-            </a:pPr>
-            <a:r>
-              <a:rPr lang="en-US" sz="1200" dirty="0">
-                <a:solidFill>
-                  <a:srgbClr val="D4AF37"/>
-                </a:solidFill>
-                <a:latin typeface="Courier New" pitchFamily="34" charset="0"/>
-                <a:ea typeface="Courier New" pitchFamily="34" charset="-122"/>
-                <a:cs typeface="Courier New" pitchFamily="34" charset="-120"/>
-              </a:rPr>
-              <a:t>github.com/briand/uv-k1-k5v3-firmware-custom</a:t>
-            </a:r>
-            <a:endParaRPr lang="en-US" sz="1200" dirty="0"/>
-          </a:p>
-        </p:txBody>
-      </p:sp>
-      <p:sp>
-        <p:nvSpPr>
-          <p:cNvPr id="13" name="Text 9"/>
-          <p:cNvSpPr txBox="1"/>
-          <p:nvPr/>
-        </p:nvSpPr>
-        <p:spPr>
-          <a:xfrm>
-            <a:off x="822960" y="4297680"/>
-            <a:ext cx="4861408" cy="320040"/>
-          </a:xfrm>
-          <a:prstGeom prst="rect">
-            <a:avLst/>
-          </a:prstGeom>
-          <a:noFill/>
-          <a:ln/>
-        </p:spPr>
-        <p:txBody>
-          <a:bodyPr wrap="square" lIns="0" tIns="0" rIns="0" bIns="0" rtlCol="0" anchor="t"/>
-          <a:lstStyle/>
-          <a:p>
-            <a:pPr algn="l" indent="0" marL="0">
-              <a:lnSpc>
-                <a:spcPct val="110000"/>
-              </a:lnSpc>
-              <a:buNone/>
-            </a:pPr>
-            <a:r>
-              <a:rPr lang="en-US" sz="1400" b="1" dirty="0">
+              <a:t>A guided Journey with an unlock map, confusion drills for the pairs you mix up, and an arcade game or five.</a:t>
+            </a:r>
+            <a:endParaRPr lang="en-US" sz="1250" dirty="0"/>
+          </a:p>
+          <a:p>
+            <a:pPr marL="177800" indent="-177800">
+              <a:lnSpc>
+                <a:spcPct val="105000"/>
+              </a:lnSpc>
+              <a:spcAft>
+                <a:spcPts val="400"/>
+              </a:spcAft>
+              <a:buSzPct val="100000"/>
+              <a:buChar char="•"/>
+            </a:pPr>
+            <a:r>
+              <a:rPr lang="en-US" sz="1250" dirty="0">
                 <a:solidFill>
                   <a:srgbClr val="F2EBDD"/>
                 </a:solidFill>
@@ -12635,80 +12875,23 @@
                 <a:ea typeface="Calibri" pitchFamily="34" charset="-122"/>
                 <a:cs typeface="Calibri" pitchFamily="34" charset="-120"/>
               </a:rPr>
-              <a:t>uvtools2 flasher and calibration backup</a:t>
-            </a:r>
-            <a:endParaRPr lang="en-US" sz="1400" dirty="0"/>
-          </a:p>
-        </p:txBody>
-      </p:sp>
-      <p:sp>
-        <p:nvSpPr>
-          <p:cNvPr id="14" name="Text 10"/>
-          <p:cNvSpPr txBox="1"/>
-          <p:nvPr/>
-        </p:nvSpPr>
-        <p:spPr>
-          <a:xfrm>
-            <a:off x="822960" y="4617720"/>
-            <a:ext cx="4861408" cy="320040"/>
-          </a:xfrm>
-          <a:prstGeom prst="rect">
-            <a:avLst/>
-          </a:prstGeom>
-          <a:noFill/>
-          <a:ln/>
-        </p:spPr>
-        <p:txBody>
-          <a:bodyPr wrap="square" lIns="0" tIns="0" rIns="0" bIns="0" rtlCol="0" anchor="t"/>
-          <a:lstStyle/>
-          <a:p>
-            <a:pPr indent="0" marL="0">
-              <a:buNone/>
-            </a:pPr>
-            <a:r>
-              <a:rPr lang="en-US" sz="1200" dirty="0">
-                <a:solidFill>
-                  <a:srgbClr val="D4AF37"/>
-                </a:solidFill>
-                <a:latin typeface="Courier New" pitchFamily="34" charset="0"/>
-                <a:ea typeface="Courier New" pitchFamily="34" charset="-122"/>
-                <a:cs typeface="Courier New" pitchFamily="34" charset="-120"/>
-              </a:rPr>
-              <a:t>armel.github.io/uvtools2</a:t>
-            </a:r>
-            <a:endParaRPr lang="en-US" sz="1200" dirty="0"/>
-          </a:p>
-        </p:txBody>
-      </p:sp>
-      <p:sp>
-        <p:nvSpPr>
-          <p:cNvPr id="15" name="Text 11"/>
-          <p:cNvSpPr txBox="1"/>
-          <p:nvPr/>
-        </p:nvSpPr>
-        <p:spPr>
-          <a:xfrm>
-            <a:off x="822960" y="5074920"/>
-            <a:ext cx="4861408" cy="320040"/>
-          </a:xfrm>
-          <a:prstGeom prst="rect">
-            <a:avLst/>
-          </a:prstGeom>
-          <a:noFill/>
-          <a:ln/>
-        </p:spPr>
-        <p:txBody>
-          <a:bodyPr wrap="square" lIns="0" tIns="0" rIns="0" bIns="0" rtlCol="0" anchor="t"/>
-          <a:lstStyle/>
-          <a:p>
-            <a:pPr algn="l" indent="0" marL="0">
-              <a:lnSpc>
-                <a:spcPct val="110000"/>
-              </a:lnSpc>
-              <a:buNone/>
-            </a:pPr>
-            <a:r>
-              <a:rPr lang="en-US" sz="1400" b="1" dirty="0">
+              <a:t>Hands-free Listen &amp; Learn for the car. Code plays, the answer is spoken.</a:t>
+            </a:r>
+            <a:endParaRPr lang="en-US" sz="1250" dirty="0"/>
+          </a:p>
+          <a:p>
+            <a:pPr marL="177800" indent="-177800">
+              <a:lnSpc>
+                <a:spcPct val="105000"/>
+              </a:lnSpc>
+              <a:spcAft>
+                <a:spcPts val="400"/>
+              </a:spcAft>
+              <a:buSzPct val="100000"/>
+              <a:buChar char="•"/>
+            </a:pPr>
+            <a:r>
+              <a:rPr lang="en-US" sz="1250" dirty="0">
                 <a:solidFill>
                   <a:srgbClr val="F2EBDD"/>
                 </a:solidFill>
@@ -12716,65 +12899,74 @@
                 <a:ea typeface="Calibri" pitchFamily="34" charset="-122"/>
                 <a:cs typeface="Calibri" pitchFamily="34" charset="-120"/>
               </a:rPr>
-              <a:t>F4HWN Fusion (upstream)</a:t>
-            </a:r>
-            <a:endParaRPr lang="en-US" sz="1400" dirty="0"/>
-          </a:p>
-        </p:txBody>
-      </p:sp>
-      <p:sp>
-        <p:nvSpPr>
-          <p:cNvPr id="16" name="Text 12"/>
-          <p:cNvSpPr txBox="1"/>
-          <p:nvPr/>
-        </p:nvSpPr>
-        <p:spPr>
-          <a:xfrm>
-            <a:off x="822960" y="5394960"/>
-            <a:ext cx="4861408" cy="320040"/>
-          </a:xfrm>
-          <a:prstGeom prst="rect">
-            <a:avLst/>
-          </a:prstGeom>
-          <a:noFill/>
-          <a:ln/>
-        </p:spPr>
-        <p:txBody>
-          <a:bodyPr wrap="square" lIns="0" tIns="0" rIns="0" bIns="0" rtlCol="0" anchor="t"/>
-          <a:lstStyle/>
-          <a:p>
-            <a:pPr indent="0" marL="0">
-              <a:buNone/>
-            </a:pPr>
-            <a:r>
-              <a:rPr lang="en-US" sz="1200" dirty="0">
-                <a:solidFill>
-                  <a:srgbClr val="D4AF37"/>
-                </a:solidFill>
-                <a:latin typeface="Courier New" pitchFamily="34" charset="0"/>
-                <a:ea typeface="Courier New" pitchFamily="34" charset="-122"/>
-                <a:cs typeface="Courier New" pitchFamily="34" charset="-120"/>
-              </a:rPr>
-              <a:t>github.com/armel/uv-k1-k5v3-firmware-custom</a:t>
-            </a:r>
-            <a:endParaRPr lang="en-US" sz="1200" dirty="0"/>
-          </a:p>
-        </p:txBody>
-      </p:sp>
-      <p:sp>
-        <p:nvSpPr>
-          <p:cNvPr id="17" name="Shape 13"/>
+              <a:t>Send it back on a touch key, a MIDI key, or a Vail adapter, with live decode. Live CW with real ops over the Vail network.</a:t>
+            </a:r>
+            <a:endParaRPr lang="en-US" sz="1250" dirty="0"/>
+          </a:p>
+          <a:p>
+            <a:pPr marL="177800" indent="-177800">
+              <a:lnSpc>
+                <a:spcPct val="105000"/>
+              </a:lnSpc>
+              <a:spcAft>
+                <a:spcPts val="400"/>
+              </a:spcAft>
+              <a:buSzPct val="100000"/>
+              <a:buChar char="•"/>
+            </a:pPr>
+            <a:r>
+              <a:rPr lang="en-US" sz="1250" dirty="0">
+                <a:solidFill>
+                  <a:srgbClr val="F2EBDD"/>
+                </a:solidFill>
+                <a:latin typeface="Calibri" pitchFamily="34" charset="0"/>
+                <a:ea typeface="Calibri" pitchFamily="34" charset="-122"/>
+                <a:cs typeface="Calibri" pitchFamily="34" charset="-120"/>
+              </a:rPr>
+              <a:t>Point the mic at your rig and decode off the air. Run a simulated pileup, a timed contest, or the 5/13/20 WPM code exam.</a:t>
+            </a:r>
+            <a:endParaRPr lang="en-US" sz="1250" dirty="0"/>
+          </a:p>
+          <a:p>
+            <a:pPr marL="177800" indent="-177800">
+              <a:lnSpc>
+                <a:spcPct val="105000"/>
+              </a:lnSpc>
+              <a:spcAft>
+                <a:spcPts val="400"/>
+              </a:spcAft>
+              <a:buSzPct val="100000"/>
+              <a:buChar char="•"/>
+            </a:pPr>
+            <a:r>
+              <a:rPr lang="en-US" sz="1250" dirty="0">
+                <a:solidFill>
+                  <a:srgbClr val="F2EBDD"/>
+                </a:solidFill>
+                <a:latin typeface="Calibri" pitchFamily="34" charset="0"/>
+                <a:ea typeface="Calibri" pitchFamily="34" charset="-122"/>
+                <a:cs typeface="Calibri" pitchFamily="34" charset="-120"/>
+              </a:rPr>
+              <a:t>Daily Dit: one five-letter word a day in Morse, same for everyone.</a:t>
+            </a:r>
+            <a:endParaRPr lang="en-US" sz="1250" dirty="0"/>
+          </a:p>
+        </p:txBody>
+      </p:sp>
+      <p:sp>
+        <p:nvSpPr>
+          <p:cNvPr id="17" name="Shape 12"/>
           <p:cNvSpPr/>
           <p:nvPr/>
         </p:nvSpPr>
         <p:spPr>
           <a:xfrm>
-            <a:off x="6233008" y="1828800"/>
-            <a:ext cx="5410048" cy="4434840"/>
+            <a:off x="8641080" y="1828800"/>
+            <a:ext cx="3001975" cy="4434840"/>
           </a:xfrm>
           <a:prstGeom prst="roundRect">
             <a:avLst>
-              <a:gd name="adj" fmla="val 2474"/>
+              <a:gd name="adj" fmla="val 3655"/>
             </a:avLst>
           </a:prstGeom>
           <a:solidFill>
@@ -12790,24 +12982,26 @@
       </p:sp>
       <p:sp>
         <p:nvSpPr>
-          <p:cNvPr id="18" name="Shape 14"/>
+          <p:cNvPr id="18" name="Shape 13"/>
           <p:cNvSpPr/>
           <p:nvPr/>
         </p:nvSpPr>
         <p:spPr>
           <a:xfrm>
-            <a:off x="6507328" y="2057400"/>
-            <a:ext cx="548640" cy="548640"/>
-          </a:xfrm>
-          <a:prstGeom prst="ellipse">
-            <a:avLst/>
+            <a:off x="8999068" y="2057400"/>
+            <a:ext cx="2286000" cy="2286000"/>
+          </a:xfrm>
+          <a:prstGeom prst="roundRect">
+            <a:avLst>
+              <a:gd name="adj" fmla="val 4000"/>
+            </a:avLst>
           </a:prstGeom>
           <a:solidFill>
-            <a:srgbClr val="D4AF37"/>
+            <a:srgbClr val="FFFFFF"/>
           </a:solidFill>
           <a:ln w="12700">
             <a:solidFill>
-              <a:srgbClr val="D4AF37"/>
+              <a:srgbClr val="FFFFFF"/>
             </a:solidFill>
             <a:prstDash val="solid"/>
           </a:ln>
@@ -12815,22 +13009,22 @@
       </p:sp>
       <p:pic>
         <p:nvPicPr>
-          <p:cNvPr id="19" name="Image 1" descr="preencoded.png">    </p:cNvPr>
+          <p:cNvPr id="19" name="Image 2" descr="/tmp/claude-0/-home-user-bkg-club/dd98b25f-744f-5b52-bca4-d25dd18876d9/scratchpad/img/amt-discord-qr.png">    </p:cNvPr>
           <p:cNvPicPr>
             <a:picLocks noChangeAspect="1"/>
           </p:cNvPicPr>
           <p:nvPr/>
         </p:nvPicPr>
         <p:blipFill>
-          <a:blip r:embed="rId2"/>
+          <a:blip r:embed="rId3"/>
           <a:stretch>
             <a:fillRect/>
           </a:stretch>
         </p:blipFill>
         <p:spPr>
           <a:xfrm>
-            <a:off x="6655460" y="2205533"/>
-            <a:ext cx="252374" cy="252374"/>
+            <a:off x="9090508" y="2148840"/>
+            <a:ext cx="2103120" cy="2103120"/>
           </a:xfrm>
           <a:prstGeom prst="rect">
             <a:avLst/>
@@ -12839,53 +13033,14 @@
       </p:pic>
       <p:sp>
         <p:nvSpPr>
-          <p:cNvPr id="20" name="Text 15"/>
-          <p:cNvSpPr txBox="1"/>
-          <p:nvPr/>
-        </p:nvSpPr>
-        <p:spPr>
-          <a:xfrm>
-            <a:off x="7193128" y="2148840"/>
-            <a:ext cx="4221328" cy="365760"/>
-          </a:xfrm>
-          <a:prstGeom prst="rect">
-            <a:avLst/>
-          </a:prstGeom>
-          <a:noFill/>
-          <a:ln/>
-        </p:spPr>
-        <p:txBody>
-          <a:bodyPr wrap="square" lIns="0" tIns="0" rIns="0" bIns="0" rtlCol="0" anchor="ctr"/>
-          <a:lstStyle/>
-          <a:p>
-            <a:pPr indent="0" marL="0">
-              <a:buNone/>
-            </a:pPr>
-            <a:r>
-              <a:rPr lang="en-US" sz="2000" b="1" dirty="0">
-                <a:solidFill>
-                  <a:srgbClr val="D4AF37"/>
-                </a:solidFill>
-                <a:latin typeface="Cambria" pitchFamily="34" charset="0"/>
-                <a:ea typeface="Cambria" pitchFamily="34" charset="-122"/>
-                <a:cs typeface="Cambria" pitchFamily="34" charset="-120"/>
-              </a:rPr>
-              <a:t>The gang</a:t>
-            </a:r>
-            <a:endParaRPr lang="en-US" sz="2000" dirty="0"/>
-          </a:p>
-        </p:txBody>
-      </p:sp>
-      <p:sp>
-        <p:nvSpPr>
-          <p:cNvPr id="21" name="Text 16"/>
-          <p:cNvSpPr txBox="1"/>
-          <p:nvPr/>
-        </p:nvSpPr>
-        <p:spPr>
-          <a:xfrm>
-            <a:off x="6507328" y="2743200"/>
-            <a:ext cx="4861408" cy="320040"/>
+          <p:cNvPr id="20" name="Text 14"/>
+          <p:cNvSpPr txBox="1"/>
+          <p:nvPr/>
+        </p:nvSpPr>
+        <p:spPr>
+          <a:xfrm>
+            <a:off x="8823960" y="4434840"/>
+            <a:ext cx="2636215" cy="320040"/>
           </a:xfrm>
           <a:prstGeom prst="rect">
             <a:avLst/>
@@ -12897,7 +13052,7 @@
           <a:bodyPr wrap="square" lIns="0" tIns="0" rIns="0" bIns="0" rtlCol="0" anchor="t"/>
           <a:lstStyle/>
           <a:p>
-            <a:pPr algn="l" indent="0" marL="0">
+            <a:pPr algn="ctr" indent="0" marL="0">
               <a:lnSpc>
                 <a:spcPct val="110000"/>
               </a:lnSpc>
@@ -12912,7 +13067,7 @@
                 <a:ea typeface="Calibri" pitchFamily="34" charset="-122"/>
                 <a:cs typeface="Calibri" pitchFamily="34" charset="-120"/>
               </a:rPr>
-              <a:t>Home, bylaws, roster, map</a:t>
+              <a:t>Scan to join the AMT Discord</a:t>
             </a:r>
             <a:endParaRPr lang="en-US" sz="1400" dirty="0"/>
           </a:p>
@@ -12920,14 +13075,14 @@
       </p:sp>
       <p:sp>
         <p:nvSpPr>
-          <p:cNvPr id="22" name="Text 17"/>
-          <p:cNvSpPr txBox="1"/>
-          <p:nvPr/>
-        </p:nvSpPr>
-        <p:spPr>
-          <a:xfrm>
-            <a:off x="6507328" y="3063240"/>
-            <a:ext cx="4861408" cy="320040"/>
+          <p:cNvPr id="21" name="Text 15"/>
+          <p:cNvSpPr txBox="1"/>
+          <p:nvPr/>
+        </p:nvSpPr>
+        <p:spPr>
+          <a:xfrm>
+            <a:off x="8823960" y="4754880"/>
+            <a:ext cx="2636215" cy="320040"/>
           </a:xfrm>
           <a:prstGeom prst="rect">
             <a:avLst/>
@@ -12939,7 +13094,7 @@
           <a:bodyPr wrap="square" lIns="0" tIns="0" rIns="0" bIns="0" rtlCol="0" anchor="t"/>
           <a:lstStyle/>
           <a:p>
-            <a:pPr indent="0" marL="0">
+            <a:pPr algn="ctr" indent="0" marL="0">
               <a:buNone/>
             </a:pPr>
             <a:r>
@@ -12951,7 +13106,7 @@
                 <a:ea typeface="Courier New" pitchFamily="34" charset="-122"/>
                 <a:cs typeface="Courier New" pitchFamily="34" charset="-120"/>
               </a:rPr>
-              <a:t>bkg.club</a:t>
+              <a:t>discord.gg/qgyk3TPUd9</a:t>
             </a:r>
             <a:endParaRPr lang="en-US" sz="1200" dirty="0"/>
           </a:p>
@@ -12959,14 +13114,14 @@
       </p:sp>
       <p:sp>
         <p:nvSpPr>
-          <p:cNvPr id="23" name="Text 18"/>
-          <p:cNvSpPr txBox="1"/>
-          <p:nvPr/>
-        </p:nvSpPr>
-        <p:spPr>
-          <a:xfrm>
-            <a:off x="6507328" y="3419856"/>
-            <a:ext cx="4861408" cy="320040"/>
+          <p:cNvPr id="22" name="Text 16"/>
+          <p:cNvSpPr txBox="1"/>
+          <p:nvPr/>
+        </p:nvSpPr>
+        <p:spPr>
+          <a:xfrm>
+            <a:off x="8915400" y="5166360"/>
+            <a:ext cx="2453335" cy="548640"/>
           </a:xfrm>
           <a:prstGeom prst="rect">
             <a:avLst/>
@@ -12978,37 +13133,37 @@
           <a:bodyPr wrap="square" lIns="0" tIns="0" rIns="0" bIns="0" rtlCol="0" anchor="t"/>
           <a:lstStyle/>
           <a:p>
-            <a:pPr algn="l" indent="0" marL="0">
+            <a:pPr algn="ctr" indent="0" marL="0">
               <a:lnSpc>
                 <a:spcPct val="110000"/>
               </a:lnSpc>
               <a:buNone/>
             </a:pPr>
             <a:r>
-              <a:rPr lang="en-US" sz="1400" b="1" dirty="0">
-                <a:solidFill>
-                  <a:srgbClr val="F2EBDD"/>
-                </a:solidFill>
-                <a:latin typeface="Calibri" pitchFamily="34" charset="0"/>
-                <a:ea typeface="Calibri" pitchFamily="34" charset="-122"/>
-                <a:cs typeface="Calibri" pitchFamily="34" charset="-120"/>
-              </a:rPr>
-              <a:t>The pitch for clubs, spelled correctly</a:t>
-            </a:r>
-            <a:endParaRPr lang="en-US" sz="1400" dirty="0"/>
-          </a:p>
-        </p:txBody>
-      </p:sp>
-      <p:sp>
-        <p:nvSpPr>
-          <p:cNvPr id="24" name="Text 19"/>
-          <p:cNvSpPr txBox="1"/>
-          <p:nvPr/>
-        </p:nvSpPr>
-        <p:spPr>
-          <a:xfrm>
-            <a:off x="6507328" y="3739896"/>
-            <a:ext cx="4861408" cy="320040"/>
+              <a:rPr lang="en-US" sz="1150" dirty="0">
+                <a:solidFill>
+                  <a:srgbClr val="B3A995"/>
+                </a:solidFill>
+                <a:latin typeface="Calibri" pitchFamily="34" charset="0"/>
+                <a:ea typeface="Calibri" pitchFamily="34" charset="-122"/>
+                <a:cs typeface="Calibri" pitchFamily="34" charset="-120"/>
+              </a:rPr>
+              <a:t>Beta invites, bug reports, feature chat, and the Android test spots.</a:t>
+            </a:r>
+            <a:endParaRPr lang="en-US" sz="1150" dirty="0"/>
+          </a:p>
+        </p:txBody>
+      </p:sp>
+      <p:sp>
+        <p:nvSpPr>
+          <p:cNvPr id="23" name="Text 17"/>
+          <p:cNvSpPr txBox="1"/>
+          <p:nvPr/>
+        </p:nvSpPr>
+        <p:spPr>
+          <a:xfrm>
+            <a:off x="8823960" y="5806440"/>
+            <a:ext cx="2636215" cy="320040"/>
           </a:xfrm>
           <a:prstGeom prst="rect">
             <a:avLst/>
@@ -13020,7 +13175,7 @@
           <a:bodyPr wrap="square" lIns="0" tIns="0" rIns="0" bIns="0" rtlCol="0" anchor="t"/>
           <a:lstStyle/>
           <a:p>
-            <a:pPr indent="0" marL="0">
+            <a:pPr algn="ctr" indent="0" marL="0">
               <a:buNone/>
             </a:pPr>
             <a:r>
@@ -13032,291 +13187,9 @@
                 <a:ea typeface="Courier New" pitchFamily="34" charset="-122"/>
                 <a:cs typeface="Courier New" pitchFamily="34" charset="-120"/>
               </a:rPr>
-              <a:t>bkg.club/clubs.html</a:t>
+              <a:t>anothermorsetrainer.app</a:t>
             </a:r>
             <a:endParaRPr lang="en-US" sz="1200" dirty="0"/>
-          </a:p>
-        </p:txBody>
-      </p:sp>
-      <p:sp>
-        <p:nvSpPr>
-          <p:cNvPr id="25" name="Text 20"/>
-          <p:cNvSpPr txBox="1"/>
-          <p:nvPr/>
-        </p:nvSpPr>
-        <p:spPr>
-          <a:xfrm>
-            <a:off x="6507328" y="4096512"/>
-            <a:ext cx="4861408" cy="320040"/>
-          </a:xfrm>
-          <a:prstGeom prst="rect">
-            <a:avLst/>
-          </a:prstGeom>
-          <a:noFill/>
-          <a:ln/>
-        </p:spPr>
-        <p:txBody>
-          <a:bodyPr wrap="square" lIns="0" tIns="0" rIns="0" bIns="0" rtlCol="0" anchor="t"/>
-          <a:lstStyle/>
-          <a:p>
-            <a:pPr algn="l" indent="0" marL="0">
-              <a:lnSpc>
-                <a:spcPct val="110000"/>
-              </a:lnSpc>
-              <a:buNone/>
-            </a:pPr>
-            <a:r>
-              <a:rPr lang="en-US" sz="1400" b="1" dirty="0">
-                <a:solidFill>
-                  <a:srgbClr val="F2EBDD"/>
-                </a:solidFill>
-                <a:latin typeface="Calibri" pitchFamily="34" charset="0"/>
-                <a:ea typeface="Calibri" pitchFamily="34" charset="-122"/>
-                <a:cs typeface="Calibri" pitchFamily="34" charset="-120"/>
-              </a:rPr>
-              <a:t>Recruit form, downline tree, nearby finder</a:t>
-            </a:r>
-            <a:endParaRPr lang="en-US" sz="1400" dirty="0"/>
-          </a:p>
-        </p:txBody>
-      </p:sp>
-      <p:sp>
-        <p:nvSpPr>
-          <p:cNvPr id="26" name="Text 21"/>
-          <p:cNvSpPr txBox="1"/>
-          <p:nvPr/>
-        </p:nvSpPr>
-        <p:spPr>
-          <a:xfrm>
-            <a:off x="6507328" y="4416552"/>
-            <a:ext cx="4861408" cy="320040"/>
-          </a:xfrm>
-          <a:prstGeom prst="rect">
-            <a:avLst/>
-          </a:prstGeom>
-          <a:noFill/>
-          <a:ln/>
-        </p:spPr>
-        <p:txBody>
-          <a:bodyPr wrap="square" lIns="0" tIns="0" rIns="0" bIns="0" rtlCol="0" anchor="t"/>
-          <a:lstStyle/>
-          <a:p>
-            <a:pPr indent="0" marL="0">
-              <a:buNone/>
-            </a:pPr>
-            <a:r>
-              <a:rPr lang="en-US" sz="1200" dirty="0">
-                <a:solidFill>
-                  <a:srgbClr val="D4AF37"/>
-                </a:solidFill>
-                <a:latin typeface="Courier New" pitchFamily="34" charset="0"/>
-                <a:ea typeface="Courier New" pitchFamily="34" charset="-122"/>
-                <a:cs typeface="Courier New" pitchFamily="34" charset="-120"/>
-              </a:rPr>
-              <a:t>bkg.club/recruit.html  ·  /tree.html  ·  /nearby.html</a:t>
-            </a:r>
-            <a:endParaRPr lang="en-US" sz="1200" dirty="0"/>
-          </a:p>
-        </p:txBody>
-      </p:sp>
-      <p:sp>
-        <p:nvSpPr>
-          <p:cNvPr id="27" name="Text 22"/>
-          <p:cNvSpPr txBox="1"/>
-          <p:nvPr/>
-        </p:nvSpPr>
-        <p:spPr>
-          <a:xfrm>
-            <a:off x="6507328" y="4773168"/>
-            <a:ext cx="4861408" cy="320040"/>
-          </a:xfrm>
-          <a:prstGeom prst="rect">
-            <a:avLst/>
-          </a:prstGeom>
-          <a:noFill/>
-          <a:ln/>
-        </p:spPr>
-        <p:txBody>
-          <a:bodyPr wrap="square" lIns="0" tIns="0" rIns="0" bIns="0" rtlCol="0" anchor="t"/>
-          <a:lstStyle/>
-          <a:p>
-            <a:pPr algn="l" indent="0" marL="0">
-              <a:lnSpc>
-                <a:spcPct val="110000"/>
-              </a:lnSpc>
-              <a:buNone/>
-            </a:pPr>
-            <a:r>
-              <a:rPr lang="en-US" sz="1400" b="1" dirty="0">
-                <a:solidFill>
-                  <a:srgbClr val="F2EBDD"/>
-                </a:solidFill>
-                <a:latin typeface="Calibri" pitchFamily="34" charset="0"/>
-                <a:ea typeface="Calibri" pitchFamily="34" charset="-122"/>
-                <a:cs typeface="Calibri" pitchFamily="34" charset="-120"/>
-              </a:rPr>
-              <a:t>Ragchew with the gang</a:t>
-            </a:r>
-            <a:endParaRPr lang="en-US" sz="1400" dirty="0"/>
-          </a:p>
-        </p:txBody>
-      </p:sp>
-      <p:sp>
-        <p:nvSpPr>
-          <p:cNvPr id="28" name="Text 23"/>
-          <p:cNvSpPr txBox="1"/>
-          <p:nvPr/>
-        </p:nvSpPr>
-        <p:spPr>
-          <a:xfrm>
-            <a:off x="6507328" y="5093208"/>
-            <a:ext cx="4861408" cy="320040"/>
-          </a:xfrm>
-          <a:prstGeom prst="rect">
-            <a:avLst/>
-          </a:prstGeom>
-          <a:noFill/>
-          <a:ln/>
-        </p:spPr>
-        <p:txBody>
-          <a:bodyPr wrap="square" lIns="0" tIns="0" rIns="0" bIns="0" rtlCol="0" anchor="t"/>
-          <a:lstStyle/>
-          <a:p>
-            <a:pPr indent="0" marL="0">
-              <a:buNone/>
-            </a:pPr>
-            <a:r>
-              <a:rPr lang="en-US" sz="1200" dirty="0">
-                <a:solidFill>
-                  <a:srgbClr val="D4AF37"/>
-                </a:solidFill>
-                <a:latin typeface="Courier New" pitchFamily="34" charset="0"/>
-                <a:ea typeface="Courier New" pitchFamily="34" charset="-122"/>
-                <a:cs typeface="Courier New" pitchFamily="34" charset="-120"/>
-              </a:rPr>
-              <a:t>discord.gg/wDs5dth22k</a:t>
-            </a:r>
-            <a:endParaRPr lang="en-US" sz="1200" dirty="0"/>
-          </a:p>
-        </p:txBody>
-      </p:sp>
-      <p:sp>
-        <p:nvSpPr>
-          <p:cNvPr id="29" name="Text 24"/>
-          <p:cNvSpPr txBox="1"/>
-          <p:nvPr/>
-        </p:nvSpPr>
-        <p:spPr>
-          <a:xfrm>
-            <a:off x="6507328" y="5449824"/>
-            <a:ext cx="4861408" cy="320040"/>
-          </a:xfrm>
-          <a:prstGeom prst="rect">
-            <a:avLst/>
-          </a:prstGeom>
-          <a:noFill/>
-          <a:ln/>
-        </p:spPr>
-        <p:txBody>
-          <a:bodyPr wrap="square" lIns="0" tIns="0" rIns="0" bIns="0" rtlCol="0" anchor="t"/>
-          <a:lstStyle/>
-          <a:p>
-            <a:pPr algn="l" indent="0" marL="0">
-              <a:lnSpc>
-                <a:spcPct val="110000"/>
-              </a:lnSpc>
-              <a:buNone/>
-            </a:pPr>
-            <a:r>
-              <a:rPr lang="en-US" sz="1400" b="1" dirty="0">
-                <a:solidFill>
-                  <a:srgbClr val="F2EBDD"/>
-                </a:solidFill>
-                <a:latin typeface="Calibri" pitchFamily="34" charset="0"/>
-                <a:ea typeface="Calibri" pitchFamily="34" charset="-122"/>
-                <a:cs typeface="Calibri" pitchFamily="34" charset="-120"/>
-              </a:rPr>
-              <a:t>BKG intro video (YouTube short)</a:t>
-            </a:r>
-            <a:endParaRPr lang="en-US" sz="1400" dirty="0"/>
-          </a:p>
-        </p:txBody>
-      </p:sp>
-      <p:sp>
-        <p:nvSpPr>
-          <p:cNvPr id="30" name="Text 25"/>
-          <p:cNvSpPr txBox="1"/>
-          <p:nvPr/>
-        </p:nvSpPr>
-        <p:spPr>
-          <a:xfrm>
-            <a:off x="6507328" y="5769864"/>
-            <a:ext cx="4861408" cy="320040"/>
-          </a:xfrm>
-          <a:prstGeom prst="rect">
-            <a:avLst/>
-          </a:prstGeom>
-          <a:noFill/>
-          <a:ln/>
-        </p:spPr>
-        <p:txBody>
-          <a:bodyPr wrap="square" lIns="0" tIns="0" rIns="0" bIns="0" rtlCol="0" anchor="t"/>
-          <a:lstStyle/>
-          <a:p>
-            <a:pPr indent="0" marL="0">
-              <a:buNone/>
-            </a:pPr>
-            <a:r>
-              <a:rPr lang="en-US" sz="1200" dirty="0">
-                <a:solidFill>
-                  <a:srgbClr val="D4AF37"/>
-                </a:solidFill>
-                <a:latin typeface="Courier New" pitchFamily="34" charset="0"/>
-                <a:ea typeface="Courier New" pitchFamily="34" charset="-122"/>
-                <a:cs typeface="Courier New" pitchFamily="34" charset="-120"/>
-              </a:rPr>
-              <a:t>youtube.com/shorts/2ZWex-8fG6M</a:t>
-            </a:r>
-            <a:endParaRPr lang="en-US" sz="1200" dirty="0"/>
-          </a:p>
-        </p:txBody>
-      </p:sp>
-      <p:sp>
-        <p:nvSpPr>
-          <p:cNvPr id="31" name="Text 26"/>
-          <p:cNvSpPr txBox="1"/>
-          <p:nvPr/>
-        </p:nvSpPr>
-        <p:spPr>
-          <a:xfrm>
-            <a:off x="548640" y="6400800"/>
-            <a:ext cx="11094415" cy="274320"/>
-          </a:xfrm>
-          <a:prstGeom prst="rect">
-            <a:avLst/>
-          </a:prstGeom>
-          <a:noFill/>
-          <a:ln/>
-        </p:spPr>
-        <p:txBody>
-          <a:bodyPr wrap="square" lIns="0" tIns="0" rIns="0" bIns="0" rtlCol="0" anchor="ctr"/>
-          <a:lstStyle/>
-          <a:p>
-            <a:pPr indent="0" marL="0">
-              <a:buNone/>
-            </a:pPr>
-            <a:r>
-              <a:rPr lang="en-US" sz="1000" dirty="0">
-                <a:solidFill>
-                  <a:srgbClr val="7D7466"/>
-                </a:solidFill>
-                <a:latin typeface="Calibri" pitchFamily="34" charset="0"/>
-                <a:ea typeface="Calibri" pitchFamily="34" charset="-122"/>
-                <a:cs typeface="Calibri" pitchFamily="34" charset="-120"/>
-              </a:rPr>
-              <a:t>Photos and schematic: NR7Y CW Firmware Docs, CC BY-NC-SA 4.0. Firmware: NR7Y, on F4HWN Fusion, egzumer and DualTachyon (Apache 2.0). Original K5 schematic by mentalDetector.</a:t>
-            </a:r>
-            <a:endParaRPr lang="en-US" sz="1000" dirty="0"/>
           </a:p>
         </p:txBody>
       </p:sp>
@@ -14273,7 +14146,7 @@
                 <a:ea typeface="Calibri" pitchFamily="34" charset="-122"/>
                 <a:cs typeface="Calibri" pitchFamily="34" charset="-120"/>
               </a:rPr>
-              <a:t>Who we are and how you get a number.</a:t>
+              <a:t>Who we are, how you get a number, and an app to learn the code.</a:t>
             </a:r>
             <a:endParaRPr lang="en-US" sz="1400" dirty="0"/>
           </a:p>
@@ -14627,6 +14500,1114 @@
               <a:t>evening</a:t>
             </a:r>
             <a:endParaRPr lang="en-US" sz="1800" dirty="0"/>
+          </a:p>
+        </p:txBody>
+      </p:sp>
+    </p:spTree>
+  </p:cSld>
+  <p:clrMapOvr>
+    <a:masterClrMapping/>
+  </p:clrMapOvr>
+</p:sld>
+</file>
+
+<file path=ppt/slides/slide20.xml><?xml version="1.0" encoding="utf-8"?>
+<p:sld xmlns:a="http://schemas.openxmlformats.org/drawingml/2006/main" xmlns:r="http://schemas.openxmlformats.org/officeDocument/2006/relationships" xmlns:p="http://schemas.openxmlformats.org/presentationml/2006/main">
+  <p:cSld name="Slide 20">
+    <p:bg>
+      <p:bgPr>
+        <a:solidFill>
+          <a:srgbClr val="141210"/>
+        </a:solidFill>
+      </p:bgPr>
+    </p:bg>
+    <p:spTree>
+      <p:nvGrpSpPr>
+        <p:cNvPr id="1" name=""/>
+        <p:cNvGrpSpPr/>
+        <p:nvPr/>
+      </p:nvGrpSpPr>
+      <p:grpSpPr>
+        <a:xfrm>
+          <a:off x="0" y="0"/>
+          <a:ext cx="0" cy="0"/>
+          <a:chOff x="0" y="0"/>
+          <a:chExt cx="0" cy="0"/>
+        </a:xfrm>
+      </p:grpSpPr>
+      <p:sp>
+        <p:nvSpPr>
+          <p:cNvPr id="3" name="Text 0"/>
+          <p:cNvSpPr txBox="1"/>
+          <p:nvPr/>
+        </p:nvSpPr>
+        <p:spPr>
+          <a:xfrm>
+            <a:off x="548640" y="384048"/>
+            <a:ext cx="11094415" cy="822960"/>
+          </a:xfrm>
+          <a:prstGeom prst="rect">
+            <a:avLst/>
+          </a:prstGeom>
+          <a:noFill/>
+          <a:ln/>
+        </p:spPr>
+        <p:txBody>
+          <a:bodyPr wrap="square" lIns="0" tIns="0" rIns="0" bIns="0" rtlCol="0" anchor="ctr"/>
+          <a:lstStyle/>
+          <a:p>
+            <a:pPr indent="0" marL="0">
+              <a:buNone/>
+            </a:pPr>
+            <a:r>
+              <a:rPr lang="en-US" sz="3600" b="1" dirty="0">
+                <a:solidFill>
+                  <a:srgbClr val="F0D27A"/>
+                </a:solidFill>
+                <a:latin typeface="Cambria" pitchFamily="34" charset="0"/>
+                <a:ea typeface="Cambria" pitchFamily="34" charset="-122"/>
+                <a:cs typeface="Cambria" pitchFamily="34" charset="-120"/>
+              </a:rPr>
+              <a:t>Links, credits, 73</a:t>
+            </a:r>
+            <a:endParaRPr lang="en-US" sz="3600" dirty="0"/>
+          </a:p>
+        </p:txBody>
+      </p:sp>
+      <p:sp>
+        <p:nvSpPr>
+          <p:cNvPr id="4" name="Text 1"/>
+          <p:cNvSpPr txBox="1"/>
+          <p:nvPr/>
+        </p:nvSpPr>
+        <p:spPr>
+          <a:xfrm>
+            <a:off x="548640" y="1188720"/>
+            <a:ext cx="11094415" cy="411480"/>
+          </a:xfrm>
+          <a:prstGeom prst="rect">
+            <a:avLst/>
+          </a:prstGeom>
+          <a:noFill/>
+          <a:ln/>
+        </p:spPr>
+        <p:txBody>
+          <a:bodyPr wrap="square" lIns="0" tIns="0" rIns="0" bIns="0" rtlCol="0" anchor="t"/>
+          <a:lstStyle/>
+          <a:p>
+            <a:pPr indent="0" marL="0">
+              <a:buNone/>
+            </a:pPr>
+            <a:r>
+              <a:rPr lang="en-US" sz="1600" i="1" dirty="0">
+                <a:solidFill>
+                  <a:srgbClr val="B3A995"/>
+                </a:solidFill>
+                <a:latin typeface="Calibri" pitchFamily="34" charset="0"/>
+                <a:ea typeface="Calibri" pitchFamily="34" charset="-122"/>
+                <a:cs typeface="Calibri" pitchFamily="34" charset="-120"/>
+              </a:rPr>
+              <a:t>Leave this slide up. Everything tonight came from these.</a:t>
+            </a:r>
+            <a:endParaRPr lang="en-US" sz="1600" dirty="0"/>
+          </a:p>
+        </p:txBody>
+      </p:sp>
+      <p:sp>
+        <p:nvSpPr>
+          <p:cNvPr id="5" name="Shape 2"/>
+          <p:cNvSpPr/>
+          <p:nvPr/>
+        </p:nvSpPr>
+        <p:spPr>
+          <a:xfrm>
+            <a:off x="548640" y="1828800"/>
+            <a:ext cx="5410048" cy="4434840"/>
+          </a:xfrm>
+          <a:prstGeom prst="roundRect">
+            <a:avLst>
+              <a:gd name="adj" fmla="val 2474"/>
+            </a:avLst>
+          </a:prstGeom>
+          <a:solidFill>
+            <a:srgbClr val="211D19"/>
+          </a:solidFill>
+          <a:ln w="12700">
+            <a:solidFill>
+              <a:srgbClr val="211D19"/>
+            </a:solidFill>
+            <a:prstDash val="solid"/>
+          </a:ln>
+        </p:spPr>
+      </p:sp>
+      <p:sp>
+        <p:nvSpPr>
+          <p:cNvPr id="6" name="Shape 3"/>
+          <p:cNvSpPr/>
+          <p:nvPr/>
+        </p:nvSpPr>
+        <p:spPr>
+          <a:xfrm>
+            <a:off x="822960" y="2057400"/>
+            <a:ext cx="548640" cy="548640"/>
+          </a:xfrm>
+          <a:prstGeom prst="ellipse">
+            <a:avLst/>
+          </a:prstGeom>
+          <a:solidFill>
+            <a:srgbClr val="D4AF37"/>
+          </a:solidFill>
+          <a:ln w="12700">
+            <a:solidFill>
+              <a:srgbClr val="D4AF37"/>
+            </a:solidFill>
+            <a:prstDash val="solid"/>
+          </a:ln>
+        </p:spPr>
+      </p:sp>
+      <p:pic>
+        <p:nvPicPr>
+          <p:cNvPr id="7" name="Image 0" descr="preencoded.png">    </p:cNvPr>
+          <p:cNvPicPr>
+            <a:picLocks noChangeAspect="1"/>
+          </p:cNvPicPr>
+          <p:nvPr/>
+        </p:nvPicPr>
+        <p:blipFill>
+          <a:blip r:embed="rId1"/>
+          <a:stretch>
+            <a:fillRect/>
+          </a:stretch>
+        </p:blipFill>
+        <p:spPr>
+          <a:xfrm>
+            <a:off x="971093" y="2205533"/>
+            <a:ext cx="252374" cy="252374"/>
+          </a:xfrm>
+          <a:prstGeom prst="rect">
+            <a:avLst/>
+          </a:prstGeom>
+        </p:spPr>
+      </p:pic>
+      <p:sp>
+        <p:nvSpPr>
+          <p:cNvPr id="8" name="Text 4"/>
+          <p:cNvSpPr txBox="1"/>
+          <p:nvPr/>
+        </p:nvSpPr>
+        <p:spPr>
+          <a:xfrm>
+            <a:off x="1508760" y="2148840"/>
+            <a:ext cx="4221328" cy="365760"/>
+          </a:xfrm>
+          <a:prstGeom prst="rect">
+            <a:avLst/>
+          </a:prstGeom>
+          <a:noFill/>
+          <a:ln/>
+        </p:spPr>
+        <p:txBody>
+          <a:bodyPr wrap="square" lIns="0" tIns="0" rIns="0" bIns="0" rtlCol="0" anchor="ctr"/>
+          <a:lstStyle/>
+          <a:p>
+            <a:pPr indent="0" marL="0">
+              <a:buNone/>
+            </a:pPr>
+            <a:r>
+              <a:rPr lang="en-US" sz="2000" b="1" dirty="0">
+                <a:solidFill>
+                  <a:srgbClr val="D4AF37"/>
+                </a:solidFill>
+                <a:latin typeface="Cambria" pitchFamily="34" charset="0"/>
+                <a:ea typeface="Cambria" pitchFamily="34" charset="-122"/>
+                <a:cs typeface="Cambria" pitchFamily="34" charset="-120"/>
+              </a:rPr>
+              <a:t>The radio</a:t>
+            </a:r>
+            <a:endParaRPr lang="en-US" sz="2000" dirty="0"/>
+          </a:p>
+        </p:txBody>
+      </p:sp>
+      <p:sp>
+        <p:nvSpPr>
+          <p:cNvPr id="9" name="Text 5"/>
+          <p:cNvSpPr txBox="1"/>
+          <p:nvPr/>
+        </p:nvSpPr>
+        <p:spPr>
+          <a:xfrm>
+            <a:off x="822960" y="2743200"/>
+            <a:ext cx="4861408" cy="320040"/>
+          </a:xfrm>
+          <a:prstGeom prst="rect">
+            <a:avLst/>
+          </a:prstGeom>
+          <a:noFill/>
+          <a:ln/>
+        </p:spPr>
+        <p:txBody>
+          <a:bodyPr wrap="square" lIns="0" tIns="0" rIns="0" bIns="0" rtlCol="0" anchor="t"/>
+          <a:lstStyle/>
+          <a:p>
+            <a:pPr algn="l" indent="0" marL="0">
+              <a:lnSpc>
+                <a:spcPct val="110000"/>
+              </a:lnSpc>
+              <a:buNone/>
+            </a:pPr>
+            <a:r>
+              <a:rPr lang="en-US" sz="1400" b="1" dirty="0">
+                <a:solidFill>
+                  <a:srgbClr val="F2EBDD"/>
+                </a:solidFill>
+                <a:latin typeface="Calibri" pitchFamily="34" charset="0"/>
+                <a:ea typeface="Calibri" pitchFamily="34" charset="-122"/>
+                <a:cs typeface="Calibri" pitchFamily="34" charset="-120"/>
+              </a:rPr>
+              <a:t>NR7Y CW firmware docs</a:t>
+            </a:r>
+            <a:endParaRPr lang="en-US" sz="1400" dirty="0"/>
+          </a:p>
+        </p:txBody>
+      </p:sp>
+      <p:sp>
+        <p:nvSpPr>
+          <p:cNvPr id="10" name="Text 6"/>
+          <p:cNvSpPr txBox="1"/>
+          <p:nvPr/>
+        </p:nvSpPr>
+        <p:spPr>
+          <a:xfrm>
+            <a:off x="822960" y="3063240"/>
+            <a:ext cx="4861408" cy="320040"/>
+          </a:xfrm>
+          <a:prstGeom prst="rect">
+            <a:avLst/>
+          </a:prstGeom>
+          <a:noFill/>
+          <a:ln/>
+        </p:spPr>
+        <p:txBody>
+          <a:bodyPr wrap="square" lIns="0" tIns="0" rIns="0" bIns="0" rtlCol="0" anchor="t"/>
+          <a:lstStyle/>
+          <a:p>
+            <a:pPr indent="0" marL="0">
+              <a:buNone/>
+            </a:pPr>
+            <a:r>
+              <a:rPr lang="en-US" sz="1200" dirty="0">
+                <a:solidFill>
+                  <a:srgbClr val="D4AF37"/>
+                </a:solidFill>
+                <a:latin typeface="Courier New" pitchFamily="34" charset="0"/>
+                <a:ea typeface="Courier New" pitchFamily="34" charset="-122"/>
+                <a:cs typeface="Courier New" pitchFamily="34" charset="-120"/>
+              </a:rPr>
+              <a:t>briand.github.io/cw-firmware-docs</a:t>
+            </a:r>
+            <a:endParaRPr lang="en-US" sz="1200" dirty="0"/>
+          </a:p>
+        </p:txBody>
+      </p:sp>
+      <p:sp>
+        <p:nvSpPr>
+          <p:cNvPr id="11" name="Text 7"/>
+          <p:cNvSpPr txBox="1"/>
+          <p:nvPr/>
+        </p:nvSpPr>
+        <p:spPr>
+          <a:xfrm>
+            <a:off x="822960" y="3520440"/>
+            <a:ext cx="4861408" cy="320040"/>
+          </a:xfrm>
+          <a:prstGeom prst="rect">
+            <a:avLst/>
+          </a:prstGeom>
+          <a:noFill/>
+          <a:ln/>
+        </p:spPr>
+        <p:txBody>
+          <a:bodyPr wrap="square" lIns="0" tIns="0" rIns="0" bIns="0" rtlCol="0" anchor="t"/>
+          <a:lstStyle/>
+          <a:p>
+            <a:pPr algn="l" indent="0" marL="0">
+              <a:lnSpc>
+                <a:spcPct val="110000"/>
+              </a:lnSpc>
+              <a:buNone/>
+            </a:pPr>
+            <a:r>
+              <a:rPr lang="en-US" sz="1400" b="1" dirty="0">
+                <a:solidFill>
+                  <a:srgbClr val="F2EBDD"/>
+                </a:solidFill>
+                <a:latin typeface="Calibri" pitchFamily="34" charset="0"/>
+                <a:ea typeface="Calibri" pitchFamily="34" charset="-122"/>
+                <a:cs typeface="Calibri" pitchFamily="34" charset="-120"/>
+              </a:rPr>
+              <a:t>Firmware + CHIRP module (Releases)</a:t>
+            </a:r>
+            <a:endParaRPr lang="en-US" sz="1400" dirty="0"/>
+          </a:p>
+        </p:txBody>
+      </p:sp>
+      <p:sp>
+        <p:nvSpPr>
+          <p:cNvPr id="12" name="Text 8"/>
+          <p:cNvSpPr txBox="1"/>
+          <p:nvPr/>
+        </p:nvSpPr>
+        <p:spPr>
+          <a:xfrm>
+            <a:off x="822960" y="3840480"/>
+            <a:ext cx="4861408" cy="320040"/>
+          </a:xfrm>
+          <a:prstGeom prst="rect">
+            <a:avLst/>
+          </a:prstGeom>
+          <a:noFill/>
+          <a:ln/>
+        </p:spPr>
+        <p:txBody>
+          <a:bodyPr wrap="square" lIns="0" tIns="0" rIns="0" bIns="0" rtlCol="0" anchor="t"/>
+          <a:lstStyle/>
+          <a:p>
+            <a:pPr indent="0" marL="0">
+              <a:buNone/>
+            </a:pPr>
+            <a:r>
+              <a:rPr lang="en-US" sz="1200" dirty="0">
+                <a:solidFill>
+                  <a:srgbClr val="D4AF37"/>
+                </a:solidFill>
+                <a:latin typeface="Courier New" pitchFamily="34" charset="0"/>
+                <a:ea typeface="Courier New" pitchFamily="34" charset="-122"/>
+                <a:cs typeface="Courier New" pitchFamily="34" charset="-120"/>
+              </a:rPr>
+              <a:t>github.com/briand/uv-k1-k5v3-firmware-custom</a:t>
+            </a:r>
+            <a:endParaRPr lang="en-US" sz="1200" dirty="0"/>
+          </a:p>
+        </p:txBody>
+      </p:sp>
+      <p:sp>
+        <p:nvSpPr>
+          <p:cNvPr id="13" name="Text 9"/>
+          <p:cNvSpPr txBox="1"/>
+          <p:nvPr/>
+        </p:nvSpPr>
+        <p:spPr>
+          <a:xfrm>
+            <a:off x="822960" y="4297680"/>
+            <a:ext cx="4861408" cy="320040"/>
+          </a:xfrm>
+          <a:prstGeom prst="rect">
+            <a:avLst/>
+          </a:prstGeom>
+          <a:noFill/>
+          <a:ln/>
+        </p:spPr>
+        <p:txBody>
+          <a:bodyPr wrap="square" lIns="0" tIns="0" rIns="0" bIns="0" rtlCol="0" anchor="t"/>
+          <a:lstStyle/>
+          <a:p>
+            <a:pPr algn="l" indent="0" marL="0">
+              <a:lnSpc>
+                <a:spcPct val="110000"/>
+              </a:lnSpc>
+              <a:buNone/>
+            </a:pPr>
+            <a:r>
+              <a:rPr lang="en-US" sz="1400" b="1" dirty="0">
+                <a:solidFill>
+                  <a:srgbClr val="F2EBDD"/>
+                </a:solidFill>
+                <a:latin typeface="Calibri" pitchFamily="34" charset="0"/>
+                <a:ea typeface="Calibri" pitchFamily="34" charset="-122"/>
+                <a:cs typeface="Calibri" pitchFamily="34" charset="-120"/>
+              </a:rPr>
+              <a:t>uvtools2 flasher and calibration backup</a:t>
+            </a:r>
+            <a:endParaRPr lang="en-US" sz="1400" dirty="0"/>
+          </a:p>
+        </p:txBody>
+      </p:sp>
+      <p:sp>
+        <p:nvSpPr>
+          <p:cNvPr id="14" name="Text 10"/>
+          <p:cNvSpPr txBox="1"/>
+          <p:nvPr/>
+        </p:nvSpPr>
+        <p:spPr>
+          <a:xfrm>
+            <a:off x="822960" y="4617720"/>
+            <a:ext cx="4861408" cy="320040"/>
+          </a:xfrm>
+          <a:prstGeom prst="rect">
+            <a:avLst/>
+          </a:prstGeom>
+          <a:noFill/>
+          <a:ln/>
+        </p:spPr>
+        <p:txBody>
+          <a:bodyPr wrap="square" lIns="0" tIns="0" rIns="0" bIns="0" rtlCol="0" anchor="t"/>
+          <a:lstStyle/>
+          <a:p>
+            <a:pPr indent="0" marL="0">
+              <a:buNone/>
+            </a:pPr>
+            <a:r>
+              <a:rPr lang="en-US" sz="1200" dirty="0">
+                <a:solidFill>
+                  <a:srgbClr val="D4AF37"/>
+                </a:solidFill>
+                <a:latin typeface="Courier New" pitchFamily="34" charset="0"/>
+                <a:ea typeface="Courier New" pitchFamily="34" charset="-122"/>
+                <a:cs typeface="Courier New" pitchFamily="34" charset="-120"/>
+              </a:rPr>
+              <a:t>armel.github.io/uvtools2</a:t>
+            </a:r>
+            <a:endParaRPr lang="en-US" sz="1200" dirty="0"/>
+          </a:p>
+        </p:txBody>
+      </p:sp>
+      <p:sp>
+        <p:nvSpPr>
+          <p:cNvPr id="15" name="Text 11"/>
+          <p:cNvSpPr txBox="1"/>
+          <p:nvPr/>
+        </p:nvSpPr>
+        <p:spPr>
+          <a:xfrm>
+            <a:off x="822960" y="5074920"/>
+            <a:ext cx="4861408" cy="320040"/>
+          </a:xfrm>
+          <a:prstGeom prst="rect">
+            <a:avLst/>
+          </a:prstGeom>
+          <a:noFill/>
+          <a:ln/>
+        </p:spPr>
+        <p:txBody>
+          <a:bodyPr wrap="square" lIns="0" tIns="0" rIns="0" bIns="0" rtlCol="0" anchor="t"/>
+          <a:lstStyle/>
+          <a:p>
+            <a:pPr algn="l" indent="0" marL="0">
+              <a:lnSpc>
+                <a:spcPct val="110000"/>
+              </a:lnSpc>
+              <a:buNone/>
+            </a:pPr>
+            <a:r>
+              <a:rPr lang="en-US" sz="1400" b="1" dirty="0">
+                <a:solidFill>
+                  <a:srgbClr val="F2EBDD"/>
+                </a:solidFill>
+                <a:latin typeface="Calibri" pitchFamily="34" charset="0"/>
+                <a:ea typeface="Calibri" pitchFamily="34" charset="-122"/>
+                <a:cs typeface="Calibri" pitchFamily="34" charset="-120"/>
+              </a:rPr>
+              <a:t>F4HWN Fusion (upstream)</a:t>
+            </a:r>
+            <a:endParaRPr lang="en-US" sz="1400" dirty="0"/>
+          </a:p>
+        </p:txBody>
+      </p:sp>
+      <p:sp>
+        <p:nvSpPr>
+          <p:cNvPr id="16" name="Text 12"/>
+          <p:cNvSpPr txBox="1"/>
+          <p:nvPr/>
+        </p:nvSpPr>
+        <p:spPr>
+          <a:xfrm>
+            <a:off x="822960" y="5394960"/>
+            <a:ext cx="4861408" cy="320040"/>
+          </a:xfrm>
+          <a:prstGeom prst="rect">
+            <a:avLst/>
+          </a:prstGeom>
+          <a:noFill/>
+          <a:ln/>
+        </p:spPr>
+        <p:txBody>
+          <a:bodyPr wrap="square" lIns="0" tIns="0" rIns="0" bIns="0" rtlCol="0" anchor="t"/>
+          <a:lstStyle/>
+          <a:p>
+            <a:pPr indent="0" marL="0">
+              <a:buNone/>
+            </a:pPr>
+            <a:r>
+              <a:rPr lang="en-US" sz="1200" dirty="0">
+                <a:solidFill>
+                  <a:srgbClr val="D4AF37"/>
+                </a:solidFill>
+                <a:latin typeface="Courier New" pitchFamily="34" charset="0"/>
+                <a:ea typeface="Courier New" pitchFamily="34" charset="-122"/>
+                <a:cs typeface="Courier New" pitchFamily="34" charset="-120"/>
+              </a:rPr>
+              <a:t>github.com/armel/uv-k1-k5v3-firmware-custom</a:t>
+            </a:r>
+            <a:endParaRPr lang="en-US" sz="1200" dirty="0"/>
+          </a:p>
+        </p:txBody>
+      </p:sp>
+      <p:sp>
+        <p:nvSpPr>
+          <p:cNvPr id="17" name="Shape 13"/>
+          <p:cNvSpPr/>
+          <p:nvPr/>
+        </p:nvSpPr>
+        <p:spPr>
+          <a:xfrm>
+            <a:off x="6233008" y="1828800"/>
+            <a:ext cx="5410048" cy="4434840"/>
+          </a:xfrm>
+          <a:prstGeom prst="roundRect">
+            <a:avLst>
+              <a:gd name="adj" fmla="val 2474"/>
+            </a:avLst>
+          </a:prstGeom>
+          <a:solidFill>
+            <a:srgbClr val="2A2520"/>
+          </a:solidFill>
+          <a:ln w="12700">
+            <a:solidFill>
+              <a:srgbClr val="2A2520"/>
+            </a:solidFill>
+            <a:prstDash val="solid"/>
+          </a:ln>
+        </p:spPr>
+      </p:sp>
+      <p:sp>
+        <p:nvSpPr>
+          <p:cNvPr id="18" name="Shape 14"/>
+          <p:cNvSpPr/>
+          <p:nvPr/>
+        </p:nvSpPr>
+        <p:spPr>
+          <a:xfrm>
+            <a:off x="6507328" y="2057400"/>
+            <a:ext cx="548640" cy="548640"/>
+          </a:xfrm>
+          <a:prstGeom prst="ellipse">
+            <a:avLst/>
+          </a:prstGeom>
+          <a:solidFill>
+            <a:srgbClr val="D4AF37"/>
+          </a:solidFill>
+          <a:ln w="12700">
+            <a:solidFill>
+              <a:srgbClr val="D4AF37"/>
+            </a:solidFill>
+            <a:prstDash val="solid"/>
+          </a:ln>
+        </p:spPr>
+      </p:sp>
+      <p:pic>
+        <p:nvPicPr>
+          <p:cNvPr id="19" name="Image 1" descr="preencoded.png">    </p:cNvPr>
+          <p:cNvPicPr>
+            <a:picLocks noChangeAspect="1"/>
+          </p:cNvPicPr>
+          <p:nvPr/>
+        </p:nvPicPr>
+        <p:blipFill>
+          <a:blip r:embed="rId2"/>
+          <a:stretch>
+            <a:fillRect/>
+          </a:stretch>
+        </p:blipFill>
+        <p:spPr>
+          <a:xfrm>
+            <a:off x="6655460" y="2205533"/>
+            <a:ext cx="252374" cy="252374"/>
+          </a:xfrm>
+          <a:prstGeom prst="rect">
+            <a:avLst/>
+          </a:prstGeom>
+        </p:spPr>
+      </p:pic>
+      <p:sp>
+        <p:nvSpPr>
+          <p:cNvPr id="20" name="Text 15"/>
+          <p:cNvSpPr txBox="1"/>
+          <p:nvPr/>
+        </p:nvSpPr>
+        <p:spPr>
+          <a:xfrm>
+            <a:off x="7193128" y="2148840"/>
+            <a:ext cx="4221328" cy="365760"/>
+          </a:xfrm>
+          <a:prstGeom prst="rect">
+            <a:avLst/>
+          </a:prstGeom>
+          <a:noFill/>
+          <a:ln/>
+        </p:spPr>
+        <p:txBody>
+          <a:bodyPr wrap="square" lIns="0" tIns="0" rIns="0" bIns="0" rtlCol="0" anchor="ctr"/>
+          <a:lstStyle/>
+          <a:p>
+            <a:pPr indent="0" marL="0">
+              <a:buNone/>
+            </a:pPr>
+            <a:r>
+              <a:rPr lang="en-US" sz="2000" b="1" dirty="0">
+                <a:solidFill>
+                  <a:srgbClr val="D4AF37"/>
+                </a:solidFill>
+                <a:latin typeface="Cambria" pitchFamily="34" charset="0"/>
+                <a:ea typeface="Cambria" pitchFamily="34" charset="-122"/>
+                <a:cs typeface="Cambria" pitchFamily="34" charset="-120"/>
+              </a:rPr>
+              <a:t>The gang</a:t>
+            </a:r>
+            <a:endParaRPr lang="en-US" sz="2000" dirty="0"/>
+          </a:p>
+        </p:txBody>
+      </p:sp>
+      <p:sp>
+        <p:nvSpPr>
+          <p:cNvPr id="21" name="Text 16"/>
+          <p:cNvSpPr txBox="1"/>
+          <p:nvPr/>
+        </p:nvSpPr>
+        <p:spPr>
+          <a:xfrm>
+            <a:off x="6507328" y="2743200"/>
+            <a:ext cx="4861408" cy="320040"/>
+          </a:xfrm>
+          <a:prstGeom prst="rect">
+            <a:avLst/>
+          </a:prstGeom>
+          <a:noFill/>
+          <a:ln/>
+        </p:spPr>
+        <p:txBody>
+          <a:bodyPr wrap="square" lIns="0" tIns="0" rIns="0" bIns="0" rtlCol="0" anchor="t"/>
+          <a:lstStyle/>
+          <a:p>
+            <a:pPr algn="l" indent="0" marL="0">
+              <a:lnSpc>
+                <a:spcPct val="110000"/>
+              </a:lnSpc>
+              <a:buNone/>
+            </a:pPr>
+            <a:r>
+              <a:rPr lang="en-US" sz="1400" b="1" dirty="0">
+                <a:solidFill>
+                  <a:srgbClr val="F2EBDD"/>
+                </a:solidFill>
+                <a:latin typeface="Calibri" pitchFamily="34" charset="0"/>
+                <a:ea typeface="Calibri" pitchFamily="34" charset="-122"/>
+                <a:cs typeface="Calibri" pitchFamily="34" charset="-120"/>
+              </a:rPr>
+              <a:t>Home, bylaws, roster, map</a:t>
+            </a:r>
+            <a:endParaRPr lang="en-US" sz="1400" dirty="0"/>
+          </a:p>
+        </p:txBody>
+      </p:sp>
+      <p:sp>
+        <p:nvSpPr>
+          <p:cNvPr id="22" name="Text 17"/>
+          <p:cNvSpPr txBox="1"/>
+          <p:nvPr/>
+        </p:nvSpPr>
+        <p:spPr>
+          <a:xfrm>
+            <a:off x="6507328" y="3063240"/>
+            <a:ext cx="4861408" cy="320040"/>
+          </a:xfrm>
+          <a:prstGeom prst="rect">
+            <a:avLst/>
+          </a:prstGeom>
+          <a:noFill/>
+          <a:ln/>
+        </p:spPr>
+        <p:txBody>
+          <a:bodyPr wrap="square" lIns="0" tIns="0" rIns="0" bIns="0" rtlCol="0" anchor="t"/>
+          <a:lstStyle/>
+          <a:p>
+            <a:pPr indent="0" marL="0">
+              <a:buNone/>
+            </a:pPr>
+            <a:r>
+              <a:rPr lang="en-US" sz="1200" dirty="0">
+                <a:solidFill>
+                  <a:srgbClr val="D4AF37"/>
+                </a:solidFill>
+                <a:latin typeface="Courier New" pitchFamily="34" charset="0"/>
+                <a:ea typeface="Courier New" pitchFamily="34" charset="-122"/>
+                <a:cs typeface="Courier New" pitchFamily="34" charset="-120"/>
+              </a:rPr>
+              <a:t>bkg.club</a:t>
+            </a:r>
+            <a:endParaRPr lang="en-US" sz="1200" dirty="0"/>
+          </a:p>
+        </p:txBody>
+      </p:sp>
+      <p:sp>
+        <p:nvSpPr>
+          <p:cNvPr id="23" name="Text 18"/>
+          <p:cNvSpPr txBox="1"/>
+          <p:nvPr/>
+        </p:nvSpPr>
+        <p:spPr>
+          <a:xfrm>
+            <a:off x="6507328" y="3419856"/>
+            <a:ext cx="4861408" cy="320040"/>
+          </a:xfrm>
+          <a:prstGeom prst="rect">
+            <a:avLst/>
+          </a:prstGeom>
+          <a:noFill/>
+          <a:ln/>
+        </p:spPr>
+        <p:txBody>
+          <a:bodyPr wrap="square" lIns="0" tIns="0" rIns="0" bIns="0" rtlCol="0" anchor="t"/>
+          <a:lstStyle/>
+          <a:p>
+            <a:pPr algn="l" indent="0" marL="0">
+              <a:lnSpc>
+                <a:spcPct val="110000"/>
+              </a:lnSpc>
+              <a:buNone/>
+            </a:pPr>
+            <a:r>
+              <a:rPr lang="en-US" sz="1400" b="1" dirty="0">
+                <a:solidFill>
+                  <a:srgbClr val="F2EBDD"/>
+                </a:solidFill>
+                <a:latin typeface="Calibri" pitchFamily="34" charset="0"/>
+                <a:ea typeface="Calibri" pitchFamily="34" charset="-122"/>
+                <a:cs typeface="Calibri" pitchFamily="34" charset="-120"/>
+              </a:rPr>
+              <a:t>The pitch for clubs, spelled correctly</a:t>
+            </a:r>
+            <a:endParaRPr lang="en-US" sz="1400" dirty="0"/>
+          </a:p>
+        </p:txBody>
+      </p:sp>
+      <p:sp>
+        <p:nvSpPr>
+          <p:cNvPr id="24" name="Text 19"/>
+          <p:cNvSpPr txBox="1"/>
+          <p:nvPr/>
+        </p:nvSpPr>
+        <p:spPr>
+          <a:xfrm>
+            <a:off x="6507328" y="3739896"/>
+            <a:ext cx="4861408" cy="320040"/>
+          </a:xfrm>
+          <a:prstGeom prst="rect">
+            <a:avLst/>
+          </a:prstGeom>
+          <a:noFill/>
+          <a:ln/>
+        </p:spPr>
+        <p:txBody>
+          <a:bodyPr wrap="square" lIns="0" tIns="0" rIns="0" bIns="0" rtlCol="0" anchor="t"/>
+          <a:lstStyle/>
+          <a:p>
+            <a:pPr indent="0" marL="0">
+              <a:buNone/>
+            </a:pPr>
+            <a:r>
+              <a:rPr lang="en-US" sz="1200" dirty="0">
+                <a:solidFill>
+                  <a:srgbClr val="D4AF37"/>
+                </a:solidFill>
+                <a:latin typeface="Courier New" pitchFamily="34" charset="0"/>
+                <a:ea typeface="Courier New" pitchFamily="34" charset="-122"/>
+                <a:cs typeface="Courier New" pitchFamily="34" charset="-120"/>
+              </a:rPr>
+              <a:t>bkg.club/clubs.html</a:t>
+            </a:r>
+            <a:endParaRPr lang="en-US" sz="1200" dirty="0"/>
+          </a:p>
+        </p:txBody>
+      </p:sp>
+      <p:sp>
+        <p:nvSpPr>
+          <p:cNvPr id="25" name="Text 20"/>
+          <p:cNvSpPr txBox="1"/>
+          <p:nvPr/>
+        </p:nvSpPr>
+        <p:spPr>
+          <a:xfrm>
+            <a:off x="6507328" y="4096512"/>
+            <a:ext cx="4861408" cy="320040"/>
+          </a:xfrm>
+          <a:prstGeom prst="rect">
+            <a:avLst/>
+          </a:prstGeom>
+          <a:noFill/>
+          <a:ln/>
+        </p:spPr>
+        <p:txBody>
+          <a:bodyPr wrap="square" lIns="0" tIns="0" rIns="0" bIns="0" rtlCol="0" anchor="t"/>
+          <a:lstStyle/>
+          <a:p>
+            <a:pPr algn="l" indent="0" marL="0">
+              <a:lnSpc>
+                <a:spcPct val="110000"/>
+              </a:lnSpc>
+              <a:buNone/>
+            </a:pPr>
+            <a:r>
+              <a:rPr lang="en-US" sz="1400" b="1" dirty="0">
+                <a:solidFill>
+                  <a:srgbClr val="F2EBDD"/>
+                </a:solidFill>
+                <a:latin typeface="Calibri" pitchFamily="34" charset="0"/>
+                <a:ea typeface="Calibri" pitchFamily="34" charset="-122"/>
+                <a:cs typeface="Calibri" pitchFamily="34" charset="-120"/>
+              </a:rPr>
+              <a:t>Recruit form, downline tree, nearby finder</a:t>
+            </a:r>
+            <a:endParaRPr lang="en-US" sz="1400" dirty="0"/>
+          </a:p>
+        </p:txBody>
+      </p:sp>
+      <p:sp>
+        <p:nvSpPr>
+          <p:cNvPr id="26" name="Text 21"/>
+          <p:cNvSpPr txBox="1"/>
+          <p:nvPr/>
+        </p:nvSpPr>
+        <p:spPr>
+          <a:xfrm>
+            <a:off x="6507328" y="4416552"/>
+            <a:ext cx="4861408" cy="320040"/>
+          </a:xfrm>
+          <a:prstGeom prst="rect">
+            <a:avLst/>
+          </a:prstGeom>
+          <a:noFill/>
+          <a:ln/>
+        </p:spPr>
+        <p:txBody>
+          <a:bodyPr wrap="square" lIns="0" tIns="0" rIns="0" bIns="0" rtlCol="0" anchor="t"/>
+          <a:lstStyle/>
+          <a:p>
+            <a:pPr indent="0" marL="0">
+              <a:buNone/>
+            </a:pPr>
+            <a:r>
+              <a:rPr lang="en-US" sz="1200" dirty="0">
+                <a:solidFill>
+                  <a:srgbClr val="D4AF37"/>
+                </a:solidFill>
+                <a:latin typeface="Courier New" pitchFamily="34" charset="0"/>
+                <a:ea typeface="Courier New" pitchFamily="34" charset="-122"/>
+                <a:cs typeface="Courier New" pitchFamily="34" charset="-120"/>
+              </a:rPr>
+              <a:t>bkg.club/recruit.html  ·  /tree.html  ·  /nearby.html</a:t>
+            </a:r>
+            <a:endParaRPr lang="en-US" sz="1200" dirty="0"/>
+          </a:p>
+        </p:txBody>
+      </p:sp>
+      <p:sp>
+        <p:nvSpPr>
+          <p:cNvPr id="27" name="Text 22"/>
+          <p:cNvSpPr txBox="1"/>
+          <p:nvPr/>
+        </p:nvSpPr>
+        <p:spPr>
+          <a:xfrm>
+            <a:off x="6507328" y="4773168"/>
+            <a:ext cx="4861408" cy="320040"/>
+          </a:xfrm>
+          <a:prstGeom prst="rect">
+            <a:avLst/>
+          </a:prstGeom>
+          <a:noFill/>
+          <a:ln/>
+        </p:spPr>
+        <p:txBody>
+          <a:bodyPr wrap="square" lIns="0" tIns="0" rIns="0" bIns="0" rtlCol="0" anchor="t"/>
+          <a:lstStyle/>
+          <a:p>
+            <a:pPr algn="l" indent="0" marL="0">
+              <a:lnSpc>
+                <a:spcPct val="110000"/>
+              </a:lnSpc>
+              <a:buNone/>
+            </a:pPr>
+            <a:r>
+              <a:rPr lang="en-US" sz="1400" b="1" dirty="0">
+                <a:solidFill>
+                  <a:srgbClr val="F2EBDD"/>
+                </a:solidFill>
+                <a:latin typeface="Calibri" pitchFamily="34" charset="0"/>
+                <a:ea typeface="Calibri" pitchFamily="34" charset="-122"/>
+                <a:cs typeface="Calibri" pitchFamily="34" charset="-120"/>
+              </a:rPr>
+              <a:t>Ragchew with the gang</a:t>
+            </a:r>
+            <a:endParaRPr lang="en-US" sz="1400" dirty="0"/>
+          </a:p>
+        </p:txBody>
+      </p:sp>
+      <p:sp>
+        <p:nvSpPr>
+          <p:cNvPr id="28" name="Text 23"/>
+          <p:cNvSpPr txBox="1"/>
+          <p:nvPr/>
+        </p:nvSpPr>
+        <p:spPr>
+          <a:xfrm>
+            <a:off x="6507328" y="5093208"/>
+            <a:ext cx="4861408" cy="320040"/>
+          </a:xfrm>
+          <a:prstGeom prst="rect">
+            <a:avLst/>
+          </a:prstGeom>
+          <a:noFill/>
+          <a:ln/>
+        </p:spPr>
+        <p:txBody>
+          <a:bodyPr wrap="square" lIns="0" tIns="0" rIns="0" bIns="0" rtlCol="0" anchor="t"/>
+          <a:lstStyle/>
+          <a:p>
+            <a:pPr indent="0" marL="0">
+              <a:buNone/>
+            </a:pPr>
+            <a:r>
+              <a:rPr lang="en-US" sz="1200" dirty="0">
+                <a:solidFill>
+                  <a:srgbClr val="D4AF37"/>
+                </a:solidFill>
+                <a:latin typeface="Courier New" pitchFamily="34" charset="0"/>
+                <a:ea typeface="Courier New" pitchFamily="34" charset="-122"/>
+                <a:cs typeface="Courier New" pitchFamily="34" charset="-120"/>
+              </a:rPr>
+              <a:t>discord.gg/wDs5dth22k</a:t>
+            </a:r>
+            <a:endParaRPr lang="en-US" sz="1200" dirty="0"/>
+          </a:p>
+        </p:txBody>
+      </p:sp>
+      <p:sp>
+        <p:nvSpPr>
+          <p:cNvPr id="29" name="Text 24"/>
+          <p:cNvSpPr txBox="1"/>
+          <p:nvPr/>
+        </p:nvSpPr>
+        <p:spPr>
+          <a:xfrm>
+            <a:off x="6507328" y="5449824"/>
+            <a:ext cx="4861408" cy="320040"/>
+          </a:xfrm>
+          <a:prstGeom prst="rect">
+            <a:avLst/>
+          </a:prstGeom>
+          <a:noFill/>
+          <a:ln/>
+        </p:spPr>
+        <p:txBody>
+          <a:bodyPr wrap="square" lIns="0" tIns="0" rIns="0" bIns="0" rtlCol="0" anchor="t"/>
+          <a:lstStyle/>
+          <a:p>
+            <a:pPr algn="l" indent="0" marL="0">
+              <a:lnSpc>
+                <a:spcPct val="110000"/>
+              </a:lnSpc>
+              <a:buNone/>
+            </a:pPr>
+            <a:r>
+              <a:rPr lang="en-US" sz="1400" b="1" dirty="0">
+                <a:solidFill>
+                  <a:srgbClr val="F2EBDD"/>
+                </a:solidFill>
+                <a:latin typeface="Calibri" pitchFamily="34" charset="0"/>
+                <a:ea typeface="Calibri" pitchFamily="34" charset="-122"/>
+                <a:cs typeface="Calibri" pitchFamily="34" charset="-120"/>
+              </a:rPr>
+              <a:t>BKG intro video (YouTube short)</a:t>
+            </a:r>
+            <a:endParaRPr lang="en-US" sz="1400" dirty="0"/>
+          </a:p>
+        </p:txBody>
+      </p:sp>
+      <p:sp>
+        <p:nvSpPr>
+          <p:cNvPr id="30" name="Text 25"/>
+          <p:cNvSpPr txBox="1"/>
+          <p:nvPr/>
+        </p:nvSpPr>
+        <p:spPr>
+          <a:xfrm>
+            <a:off x="6507328" y="5769864"/>
+            <a:ext cx="4861408" cy="320040"/>
+          </a:xfrm>
+          <a:prstGeom prst="rect">
+            <a:avLst/>
+          </a:prstGeom>
+          <a:noFill/>
+          <a:ln/>
+        </p:spPr>
+        <p:txBody>
+          <a:bodyPr wrap="square" lIns="0" tIns="0" rIns="0" bIns="0" rtlCol="0" anchor="t"/>
+          <a:lstStyle/>
+          <a:p>
+            <a:pPr indent="0" marL="0">
+              <a:buNone/>
+            </a:pPr>
+            <a:r>
+              <a:rPr lang="en-US" sz="1200" dirty="0">
+                <a:solidFill>
+                  <a:srgbClr val="D4AF37"/>
+                </a:solidFill>
+                <a:latin typeface="Courier New" pitchFamily="34" charset="0"/>
+                <a:ea typeface="Courier New" pitchFamily="34" charset="-122"/>
+                <a:cs typeface="Courier New" pitchFamily="34" charset="-120"/>
+              </a:rPr>
+              <a:t>youtube.com/shorts/2ZWex-8fG6M</a:t>
+            </a:r>
+            <a:endParaRPr lang="en-US" sz="1200" dirty="0"/>
+          </a:p>
+        </p:txBody>
+      </p:sp>
+      <p:sp>
+        <p:nvSpPr>
+          <p:cNvPr id="31" name="Text 26"/>
+          <p:cNvSpPr txBox="1"/>
+          <p:nvPr/>
+        </p:nvSpPr>
+        <p:spPr>
+          <a:xfrm>
+            <a:off x="548640" y="6400800"/>
+            <a:ext cx="11094415" cy="274320"/>
+          </a:xfrm>
+          <a:prstGeom prst="rect">
+            <a:avLst/>
+          </a:prstGeom>
+          <a:noFill/>
+          <a:ln/>
+        </p:spPr>
+        <p:txBody>
+          <a:bodyPr wrap="square" lIns="0" tIns="0" rIns="0" bIns="0" rtlCol="0" anchor="ctr"/>
+          <a:lstStyle/>
+          <a:p>
+            <a:pPr indent="0" marL="0">
+              <a:buNone/>
+            </a:pPr>
+            <a:r>
+              <a:rPr lang="en-US" sz="1000" dirty="0">
+                <a:solidFill>
+                  <a:srgbClr val="7D7466"/>
+                </a:solidFill>
+                <a:latin typeface="Calibri" pitchFamily="34" charset="0"/>
+                <a:ea typeface="Calibri" pitchFamily="34" charset="-122"/>
+                <a:cs typeface="Calibri" pitchFamily="34" charset="-120"/>
+              </a:rPr>
+              <a:t>Photos and schematic: NR7Y CW Firmware Docs, CC BY-NC-SA 4.0. Firmware: NR7Y, on F4HWN Fusion, egzumer and DualTachyon (Apache 2.0). Original K5 schematic by mentalDetector.</a:t>
+            </a:r>
+            <a:endParaRPr lang="en-US" sz="1000" dirty="0"/>
           </a:p>
         </p:txBody>
       </p:sp>

</xml_diff>

<commit_message>
Retitle the talk deck's roadmap slide to On the agenda
Co-Authored-By: Claude Fable 5.1 <noreply@anthropic.com>
Claude-Session: https://claude.ai/code/session_01KDZck9uBeSHBv7szzYQxJN
</commit_message>
<xml_diff>
--- a/docs/talks/quansheng-2m-cw/quansheng-2m-cw.pptx
+++ b/docs/talks/quansheng-2m-cw/quansheng-2m-cw.pptx
@@ -13258,7 +13258,7 @@
                 <a:ea typeface="Cambria" pitchFamily="34" charset="-122"/>
                 <a:cs typeface="Cambria" pitchFamily="34" charset="-120"/>
               </a:rPr>
-              <a:t>Tonight</a:t>
+              <a:t>On the agenda</a:t>
             </a:r>
             <a:endParaRPr lang="en-US" sz="3600" dirty="0"/>
           </a:p>
@@ -14607,7 +14607,7 @@
                 <a:ea typeface="Calibri" pitchFamily="34" charset="-122"/>
                 <a:cs typeface="Calibri" pitchFamily="34" charset="-120"/>
               </a:rPr>
-              <a:t>Leave this slide up. Everything tonight came from these.</a:t>
+              <a:t>Leave this slide up. Everything in this talk came from these.</a:t>
             </a:r>
             <a:endParaRPr lang="en-US" sz="1600" dirty="0"/>
           </a:p>

</xml_diff>